<commit_message>
Publish full MNIST five-path results and presentation
</commit_message>
<xml_diff>
--- a/presentation/CNN_CUDA_Case_Study.pptx
+++ b/presentation/CNN_CUDA_Case_Study.pptx
@@ -148,7 +148,7 @@
     </p:spTree>
     <p:extLst>
       <p:ext uri="{BB962C8B-B14F-4D97-AF65-F5344CB8AC3E}">
-        <p14:creationId xmlns:p14="http://schemas.microsoft.com/office/powerpoint/2010/main" val="348986193"/>
+        <p14:creationId xmlns:p14="http://schemas.microsoft.com/office/powerpoint/2010/main" val="4244835699"/>
       </p:ext>
     </p:extLst>
   </p:cSld>
@@ -294,7 +294,7 @@
           <a:p>
             <a:r>
               <a:rPr lang="en-US"/>
-              <a:t>CNN CUDA Case Study. Prithiv explains the CNN and CPU; Satya explains CUDA and DataParallel; Roydon presents measured results and runs the saved checkpoint demo. The cover is followed by eleven content slides.</a:t>
+              <a:t>CNN CUDA Case Study. Prithiv explains the CNN and CPU, Satya explains CUDA and DataParallel, and Roydon presents the measured results and checkpoint demo. Full MNIST: 48,000 train, 12,000 validation and 10,000 test images. All five paths run 50 epochs with the prescribed setup.</a:t>
             </a:r>
             <a:endParaRPr lang="en-US" dirty="0"/>
           </a:p>
@@ -383,19 +383,9 @@
             <a:r>
               <a:rPr lang="en-US"/>
               <a:t>Roydon
-The operation column measures one convolution on a single digit: input 1x1x28x28, four 3x3 filters, bias and output allocation. Inference measures the entire CNN forward pass. Both are warmed medians of completed-call wall latency with input resident on the device. Batch infer/s uses a batch of 64, unlike the one-image columns.
-PyTorch CPU has the lowest single-image inference latency. Custom CUDA has the highest batch-64 inference throughput in this runtime. These two workload scopes need not have the same winner. DataParallel single-image calls use one replica and still pay wrapper costs.
-The handwritten C++ convolution, benchmarked separately, takes 124.06 us with one worker and 66.32 us with OpenMP. At batch 64, it improves from 6608.54 to 2244.91 us: 2.94x on four logical workers. Do not confuse that native baseline with optimized PyTorch CPU convolution. The tiled custom CUDA variant was also benchmarked, but did not improve the direct kernel in any saved case.
-Measured implementation: https://github.com/saltypal/CNN-CUDA-Case-Study/tree/370e8a418f76c32129057a95eb7993f19095cd3f/src/hpc_cnn</a:t>
-            </a:r>
-          </a:p>
-          <a:p>
-            <a:endParaRPr lang="en-US"/>
-          </a:p>
-          <a:p>
-            <a:r>
-              <a:rPr lang="en-US"/>
-              <a:t>Bars are actual 50-epoch training times. Speedup T1/T2: CUDA 0.379, cuDNN 0.366, PyTorch 0.295. Efficiencies: 18.96%,18.30%,14.74%. GPU-time ratios:5.27,5.47,6.78. No batch-size sweep or utilization telemetry was measured.</a:t>
+Matching one- and two-GPU engines retain global batch 64. Training speedup is T1/T2. Efficiency is T1/(2*T2). GPU-time cost ratio is 2*T2/T1, a time-based resource proxy. cuDNN: speedup 0.377, efficiency 18.85%, GPU-time ratio 5.31; PyTorch: speedup 0.279, efficiency 13.96%, GPU-time ratio 7.16.
+DataParallel adds replication, scatter, gather and gradient reduction. Using more training images increases the number of steps; it does not increase the per-GPU batch, which remains 32. No detailed profiler attribution was collected to assign an exact overhead percentage to each component. No utilization telemetry or batch-size sweep was measured. Energy was not measured and no currency rate was supplied.
+https://github.com/saltypal/CNN-CUDA-Case-Study/tree/42624fca4ba9b278076097e076363057b2d32a27/src/hpc_cnn</a:t>
             </a:r>
             <a:endParaRPr lang="en-US" dirty="0"/>
           </a:p>
@@ -484,19 +474,9 @@
             <a:r>
               <a:rPr lang="en-US"/>
               <a:t>Roydon
-The comparison holds the global batch at 64 and uses the matching one-GPU engine as the baseline. Training speedup is T1/T2. Efficiency is speedup divided by two. A speedup below one means the two-GPU run took longer. GPU-time cost is 2*T2/T1, a time-based resource proxy rather than monetary billing, energy or Kaggle quota use.
-The small convolution does not supply enough per-replica work to compensate for replication, host dispatch, scattering, gathering and gradient reduction. These costs are real, but no profiling attribution was collected to prove what exact percentage each contributes. The report saves host enqueue, instrumented device intervals, transfers and an identity DataParallel diagnostic; the latter is not an exact subtraction of CNN communication cost.
-Energy was not measured. No monetary rate was provided. Logical tensor bytes and FLOP counts, measured memory and timing are separate quantities. For this model, one GPU is the better training choice.
-Measured implementation: https://github.com/saltypal/CNN-CUDA-Case-Study/tree/370e8a418f76c32129057a95eb7993f19095cd3f/src/hpc_cnn</a:t>
-            </a:r>
-          </a:p>
-          <a:p>
-            <a:endParaRPr lang="en-US"/>
-          </a:p>
-          <a:p>
-            <a:r>
-              <a:rPr lang="en-US"/>
-              <a:t>The displayed max error is the maximum absolute error among all forward validation checks against the framework reference; it is not a gradient-error maximum or a training accuracy difference.</a:t>
+All five final models were evaluated on the complete official 10,000-image test set. Accuracy: PyTorch CPU: 97.13%; cuDNN: 97.17%; cuDNN DP: 97.17%; PyTorch: 97.17%; PyTorch DP: 97.15%. These are separately trained final checkpoints; reduction order can create small differences in training trajectories. Final predictions need not be byte-identical.
+All 119 numerical validation checks passed. The maximum forward absolute error at matched input and weights is 3.58e-07; it is not a final training accuracy difference or gradient error maximum. The independent audit checked every test prediction, exact dataset coverage, identical initial parameter bytes, exact split indices, 50 epoch histories, timing sums and Git provenance.
+Source: https://github.com/saltypal/CNN-CUDA-Case-Study/tree/42624fca4ba9b278076097e076363057b2d32a27/src/hpc_cnn</a:t>
             </a:r>
             <a:endParaRPr lang="en-US" dirty="0"/>
           </a:p>
@@ -585,12 +565,11 @@
             <a:r>
               <a:rPr lang="en-US"/>
               <a:t>Roydon
-Conclude with the workload, not a blanket CPU-versus-GPU claim. The CPU wins single-image latency in this run; one GPU wins training and batched throughput. More GPUs are useful only when additional parallel compute exceeds orchestration and communication costs. Every final model has 95.6% test accuracy.
-Demo: load the seven final checkpoints and predict the same held-out digits. The script already ran successfully in the completed Kaggle notebook. It does not retrain. Its cold loading time is not the warmed inference benchmark.
+Discuss measured workloads rather than a universal GPU ranking. Lowest training time: PyTorch, 50.80 s. Lowest single-digit inference latency: PyTorch CPU, 88.96 microseconds. Highest batch-64 inference throughput: PyTorch, 180,668 images/s.
+Demo: load all five final checkpoints and predict the same full-test-set digits. This does not retrain. Cold checkpoint loading is separate from warmed latency. Run in the completed two-GPU Kaggle environment:
 cd /kaggle/working/cnn-cuda-case-study-source
-PYTHONPATH=src python -m hpc_cnn.demo --run-root /kaggle/working/cnn-cuda-case-study-results
-A live run of all paths requires two GPUs. Keep the saved logs and predictions ready as an offline backup. The experiment is one seed and one runtime.
-Measured implementation: https://github.com/saltypal/CNN-CUDA-Case-Study/tree/370e8a418f76c32129057a95eb7993f19095cd3f/src/hpc_cnn</a:t>
+PYTHONPATH=src python -m hpc_cnn.demo --config /kaggle/working/cnn-cuda-case-study-full-mnist-results/run_config_full_mnist.json --run-root /kaggle/working/cnn-cuda-case-study-full-mnist-results
+Source: https://github.com/saltypal/CNN-CUDA-Case-Study/tree/42624fca4ba9b278076097e076363057b2d32a27/src/hpc_cnn</a:t>
             </a:r>
             <a:endParaRPr lang="en-US" dirty="0"/>
           </a:p>
@@ -682,7 +661,7 @@
 Follow the picture from input to predicted digit. A filter performs a weighted sum over a small image patch. The same learned weights scan every location. Multiple filters learn different responses. ReLU replaces negative responses with zero; max pooling retains the largest response in each 2x2 region.
 The actual shapes are 1x28x28 -&gt; 4x26x26 -&gt; 4x13x13 -&gt; 676 -&gt; 10 logits. The CNN has 6,810 parameters. Cross entropy compares the scores with the true label; backpropagation and SGD adjust the weights. The illustration is conceptual, not a captured activation from a trained model.
 Reference: https://docs.pytorch.org/docs/2.9/generated/torch.nn.Conv2d.html
-Measured implementation: https://github.com/saltypal/CNN-CUDA-Case-Study/tree/370e8a418f76c32129057a95eb7993f19095cd3f/src/hpc_cnn</a:t>
+Measured implementation: https://github.com/saltypal/CNN-CUDA-Case-Study/tree/42624fca4ba9b278076097e076363057b2d32a27/src/hpc_cnn</a:t>
             </a:r>
             <a:endParaRPr lang="en-US" dirty="0"/>
           </a:p>
@@ -774,7 +753,7 @@
 The arithmetic stays the same. Each output is bias plus the sum of input*weight products in its receptive field. Different outputs do not depend on each other, so they can have separate workers and separate writers. The image has 2,704 outputs; batch 64 has 173,056. This makes convolution a useful source of data parallelism.
 Parallelism is most useful when there is enough work to offset scheduling and communication. It also appears in other CNN operations. Weight gradients require combining contributions because every image uses the same filter weights; the optimizer waits for those gradients. Parallel layers do not remove the forward -&gt; loss -&gt; backward dependency.
 The toy diagram shows four outputs. Worker icons are conceptual, not physical-core counts.
-Measured implementation: https://github.com/saltypal/CNN-CUDA-Case-Study/tree/370e8a418f76c32129057a95eb7993f19095cd3f/src/hpc_cnn</a:t>
+Measured implementation: https://github.com/saltypal/CNN-CUDA-Case-Study/tree/42624fca4ba9b278076097e076363057b2d32a27/src/hpc_cnn</a:t>
             </a:r>
             <a:endParaRPr lang="en-US" dirty="0"/>
           </a:p>
@@ -867,7 +846,8 @@
 Caches reuse nearby image data. OpenMP adds threads; SIMD vectorization is a separate mechanism, and its exact use was not inspected. Several CPU workers still share memory resources. These are practical limits to ideal scaling, not proof of a specific bottleneck percentage.
 The illustration shows read-only input and weights feeding separate output owners. The native CPU microbenchmark is distinct from PyTorch CPU training.
 Reference: https://www.openmp.org/spec-html/5.2/openmpse66.html
-Measured implementation: https://github.com/saltypal/CNN-CUDA-Case-Study/tree/370e8a418f76c32129057a95eb7993f19095cd3f/src/hpc_cnn</a:t>
+Measured implementation: https://github.com/saltypal/CNN-CUDA-Case-Study/tree/42624fca4ba9b278076097e076363057b2d32a27/src/hpc_cnn
+Full-run native operation benchmark at batch 64: serial 6734.15 us; four OpenMP workers 2242.33 us. This is distinct from PyTorch CPU training.</a:t>
             </a:r>
             <a:endParaRPr lang="en-US" dirty="0"/>
           </a:p>
@@ -960,7 +940,7 @@
 CNN convolution exposes many similar independent sums. Bigger batches and feature maps provide more work for GPU scheduling. Moving tensors to a separate device and submitting kernels still costs time. These benchmarks distinguish resident data from transfer costs.
 The chip illustration is conceptual and does not claim an exact hardware core count.
 Reference: https://docs.nvidia.com/cuda/archive/12.8.0/cuda-c-programming-guide/index.html
-Measured implementation: https://github.com/saltypal/CNN-CUDA-Case-Study/tree/370e8a418f76c32129057a95eb7993f19095cd3f/src/hpc_cnn</a:t>
+Measured implementation: https://github.com/saltypal/CNN-CUDA-Case-Study/tree/42624fca4ba9b278076097e076363057b2d32a27/src/hpc_cnn</a:t>
             </a:r>
             <a:endParaRPr lang="en-US" dirty="0"/>
           </a:p>
@@ -1049,11 +1029,10 @@
             <a:r>
               <a:rPr lang="en-US"/>
               <a:t>Satya
-CUDA is NVIDIA's programming platform for this GPU work. The CPU launches a grid of blocks; the GPU schedules the blocks on streaming multiprocessors. Our direct convolution uses one logical thread per output, with 256 threads per block. Logical threads are not equivalent to physical CUDA cores, and all threads need not execute simultaneously.
-Threads accumulate products using the same kernel code and different indices. Shared-memory tiling can reduce repeated source-level reads, but cooperative loading and barriers add cost. In the saved measurements it was slower than direct CUDA.
-The host launch is asynchronous. A completed-call wall measurement synchronizes before stopping the timer; enqueue time alone would not measure convolution completion.
+CUDA supplies the execution platform for cuDNN and PyTorch GPU operations. The host submits kernel launches; GPU blocks and threads perform the numerical work. Libraries choose the actual thread/block mapping. The diagram shows the hierarchy conceptually and does not claim a traced block size or physical-core count.
+Registers and shared memory can support local data reuse; global memory stores tensors. Thread blocks are scheduled onto streaming multiprocessors. Launches are asynchronous, so completed-call wall timing waits for GPU work to finish. Inputs are already resident for the operation benchmarks.
 Reference: https://docs.nvidia.com/cuda/archive/12.8.0/cuda-c-programming-guide/index.html
-Measured implementation: https://github.com/saltypal/CNN-CUDA-Case-Study/tree/370e8a418f76c32129057a95eb7993f19095cd3f/src/hpc_cnn</a:t>
+Source: https://github.com/saltypal/CNN-CUDA-Case-Study/tree/42624fca4ba9b278076097e076363057b2d32a27/src/hpc_cnn</a:t>
             </a:r>
             <a:endParaRPr lang="en-US" dirty="0"/>
           </a:p>
@@ -1142,10 +1121,10 @@
             <a:r>
               <a:rPr lang="en-US"/>
               <a:t>Satya
-A kernel is a device function executed by many CUDA threads. Our index is blockIdx.x*blockDim.x+threadIdx.x. Each valid thread decodes its sample, filter, row and column, then writes one complete output. The first layer has one input channel and four 3x3 filters, so each output uses nine multiply-accumulates plus bias.
-All programs share ReLU, pooling, linear classifier, cross entropy and SGD. The controlled comparison changes convolution and, for two-GPU runs, the DataParallel wrapper. Custom backward kernels compute parameter gradients using partial sums and a block reduction. Input gradients are supported and validated, but raw MNIST input does not require them during training.
-Direct cuDNN uses fixed convolution algorithms through its C API. PyTorch GPU also used cuDNN in the observed trace. No Tensor Core usage was verified. The three paths represent program/API and algorithm choices, not three different GPU hardware types.
-Measured implementation: https://github.com/saltypal/CNN-CUDA-Case-Study/tree/370e8a418f76c32129057a95eb7993f19095cd3f/src/hpc_cnn</a:t>
+A CUDA kernel is a GPU function executed by many threads. The direct cuDNN path uses forward algorithm 0, IMPLICIT_GEMM. Conceptually, image patches supply matrix rows, filter weights supply matrix columns, and dot products produce output values. At batch 64, the conceptual matrices are 43,264-by-9 image patches and 9-by-4 filter weights, producing 43,264-by-4 outputs. The library computes this matrix product without explicitly materializing the complete patch matrix. Threads collaborate on the library's chosen work tiles. Actual block dimensions and Tensor Core usage were not verified.
+PyTorch supplies tensors, autograd, ReLU, pooling, the linear classifier, cross entropy and SGD. The direct cuDNN adapter binds the C library and fixes convolution algorithms. PyTorch GPU also dispatches cuDNN in the observed trace. CUDA supplies device execution beneath both GPU paths; it is not a separate handwritten implementation in this study. Library backward kernels compute convolution gradients, and DataParallel sums replica contributions.
+Reference: https://docs.nvidia.com/deeplearning/cudnn/backend/v9.20.0/api/cudnn-ops-library.html#cudnnconvolutionfwdalgo-t
+Source: https://github.com/saltypal/CNN-CUDA-Case-Study/tree/42624fca4ba9b278076097e076363057b2d32a27/src/hpc_cnn</a:t>
             </a:r>
             <a:endParaRPr lang="en-US" dirty="0"/>
           </a:p>
@@ -1237,7 +1216,7 @@
 PyTorch DataParallel replicates the module, scatters the batch, runs each replica and gathers outputs on the primary device. We compute one mean cross-entropy loss over the gathered batch. Backward sums both replicas' parameter gradients into the original module; one SGD optimizer updates it.
 The global batch remains 64 instead of increasing to 128, which preserves the experiment workload and optimizer behavior. Our native wrappers use the tensor's device and current stream; direct cuDNN state is cached by device. A batch of one creates only one useful input chunk, so single-image latency does not benefit from a second replica.
 Reference: https://docs.pytorch.org/docs/main/generated/torch.nn.DataParallel.html
-Measured implementation: https://github.com/saltypal/CNN-CUDA-Case-Study/tree/370e8a418f76c32129057a95eb7993f19095cd3f/src/hpc_cnn</a:t>
+Measured implementation: https://github.com/saltypal/CNN-CUDA-Case-Study/tree/42624fca4ba9b278076097e076363057b2d32a27/src/hpc_cnn</a:t>
             </a:r>
             <a:endParaRPr lang="en-US" dirty="0"/>
           </a:p>
@@ -1326,19 +1305,10 @@
             <a:r>
               <a:rPr lang="en-US"/>
               <a:t>Roydon
-All seven models completed 50 epochs on Kaggle T4 x2. The balanced 10% MNIST subset contains 4,800 training, 1,200 validation and 1,000 test images. Seed 42, batch 64, identical initial weights, FP32, SGD learning rate 0.05 and momentum 0.9 are shared. TF32 is disabled. All 170 correctness checks passed.
-Training time sums synchronized training epochs and excludes warmup, validation, initial transfer and checkpoint I/O. All final epoch-50 checkpoints predict 956 of 1,000 test examples correctly. PyTorch with one GPU is fastest here at 5.42 s; CPU takes 10.17 s. Two-GPU DataParallel is slower than its matching one-GPU path.
-This is one seed and one runtime. It is a case study rather than a universal hardware ranking.
-Measured implementation: https://github.com/saltypal/CNN-CUDA-Case-Study/tree/370e8a418f76c32129057a95eb7993f19095cd3f/src/hpc_cnn</a:t>
-            </a:r>
-          </a:p>
-          <a:p>
-            <a:endParaRPr lang="en-US"/>
-          </a:p>
-          <a:p>
-            <a:r>
-              <a:rPr lang="en-US"/>
-              <a:t>Training time is the sum of synchronized epochs. Batch/s measures full-CNN inference at batch 64, not training throughput. Source commit: 370e8a418f76c32129057a95eb7993f19095cd3f.</a:t>
+Full MNIST uses all 60,000 development images, split 48,000 train and 12,000 validation, and all 10,000 separate official test images. Splits preserve digit proportions. The same initial bytes, exact splits, per-epoch shuffle, FP32 precision, global batch 64, seed 42, SGD learning rate 0.05 and momentum 0.9 are used in every path. TF32 is disabled. Each path completes 50 epochs and 37,500 optimizer steps.
+Training sums synchronized training epochs, excluding warmup, validation, initial upload and checkpoint I/O. Conv and inference are warmed median completed-call wall times for one resident digit. Batch/s uses full-CNN inference at batch 64. Single-image DataParallel uses one replica. No energy or monetary rate was measured.
+Final test accuracy: PyTorch CPU: 97.13%; cuDNN: 97.17%; cuDNN DP: 97.17%; PyTorch: 97.17%; PyTorch DP: 97.15%. This is one seed and one runtime. Full-data timings are measured anew and are not extrapolated from the earlier 10% study.
+Source: https://github.com/saltypal/CNN-CUDA-Case-Study/tree/42624fca4ba9b278076097e076363057b2d32a27/src/hpc_cnn</a:t>
             </a:r>
             <a:endParaRPr lang="en-US" dirty="0"/>
           </a:p>
@@ -3666,12 +3636,12 @@
               <a:buNone/>
             </a:pPr>
             <a:r>
-              <a:rPr lang="de-DE" sz="1200">
+              <a:rPr lang="en-US" sz="1200">
                 <a:solidFill>
                   <a:srgbClr val="7E8A97"/>
                 </a:solidFill>
               </a:rPr>
-              <a:t>50 epochs · 10% MNIST · Kaggle T4 ×2</a:t>
+              <a:t>50 epochs · Full MNIST · Kaggle T4 ×2</a:t>
             </a:r>
             <a:endParaRPr lang="en-US" sz="1200" dirty="0"/>
           </a:p>
@@ -3819,7 +3789,7 @@
                   <a:srgbClr val="7E8A97"/>
                 </a:solidFill>
               </a:rPr>
-              <a:t>Matching engines, same global batch 64. Extra GPUs increased training time for this small CNN.</a:t>
+              <a:t>Matching engines, same global batch 64. Two GPUs increased training time in the full-MNIST run.</a:t>
             </a:r>
             <a:endParaRPr lang="en-US" sz="1150" dirty="0"/>
           </a:p>
@@ -4044,8 +4014,8 @@
         </p:nvSpPr>
         <p:spPr>
           <a:xfrm>
-            <a:off x="1828800" y="4461672"/>
-            <a:ext cx="411480" cy="846928"/>
+            <a:off x="2286000" y="4435621"/>
+            <a:ext cx="411480" cy="872979"/>
           </a:xfrm>
           <a:prstGeom prst="rect">
             <a:avLst/>
@@ -4071,8 +4041,8 @@
         </p:nvSpPr>
         <p:spPr>
           <a:xfrm>
-            <a:off x="2331720" y="3075040"/>
-            <a:ext cx="411480" cy="2233560"/>
+            <a:off x="2857500" y="2992612"/>
+            <a:ext cx="411480" cy="2315988"/>
           </a:xfrm>
           <a:prstGeom prst="rect">
             <a:avLst/>
@@ -4098,8 +4068,8 @@
         </p:nvSpPr>
         <p:spPr>
           <a:xfrm>
-            <a:off x="1783080" y="5431536"/>
-            <a:ext cx="1005840" cy="182880"/>
+            <a:off x="2159000" y="5431536"/>
+            <a:ext cx="1524000" cy="182880"/>
           </a:xfrm>
           <a:prstGeom prst="rect">
             <a:avLst/>
@@ -4122,7 +4092,7 @@
                   <a:srgbClr val="C7D0D9"/>
                 </a:solidFill>
               </a:rPr>
-              <a:t>CUDA</a:t>
+              <a:t>cuDNN</a:t>
             </a:r>
             <a:endParaRPr lang="en-US" sz="1050" dirty="0"/>
           </a:p>
@@ -4136,8 +4106,8 @@
         </p:nvSpPr>
         <p:spPr>
           <a:xfrm>
-            <a:off x="3337560" y="4423114"/>
-            <a:ext cx="411480" cy="885486"/>
+            <a:off x="4381500" y="4598933"/>
+            <a:ext cx="411480" cy="709667"/>
           </a:xfrm>
           <a:prstGeom prst="rect">
             <a:avLst/>
@@ -4163,8 +4133,8 @@
         </p:nvSpPr>
         <p:spPr>
           <a:xfrm>
-            <a:off x="3840480" y="2888607"/>
-            <a:ext cx="411480" cy="2419993"/>
+            <a:off x="4953000" y="2766467"/>
+            <a:ext cx="411480" cy="2542133"/>
           </a:xfrm>
           <a:prstGeom prst="rect">
             <a:avLst/>
@@ -4190,100 +4160,8 @@
         </p:nvSpPr>
         <p:spPr>
           <a:xfrm>
-            <a:off x="3291840" y="5431536"/>
-            <a:ext cx="1005840" cy="182880"/>
-          </a:xfrm>
-          <a:prstGeom prst="rect">
-            <a:avLst/>
-          </a:prstGeom>
-          <a:noFill/>
-          <a:ln/>
-        </p:spPr>
-        <p:txBody>
-          <a:bodyPr wrap="square" lIns="0" tIns="0" rIns="0" bIns="0" rtlCol="0" anchor="ctr">
-            <a:noAutofit/>
-          </a:bodyPr>
-          <a:lstStyle/>
-          <a:p>
-            <a:pPr marL="0" indent="0" algn="ctr">
-              <a:buNone/>
-            </a:pPr>
-            <a:r>
-              <a:rPr lang="en-US" sz="1050">
-                <a:solidFill>
-                  <a:srgbClr val="C7D0D9"/>
-                </a:solidFill>
-              </a:rPr>
-              <a:t>cuDNN</a:t>
-            </a:r>
-            <a:endParaRPr lang="en-US" sz="1050" dirty="0"/>
-          </a:p>
-        </p:txBody>
-      </p:sp>
-      <p:sp>
-        <p:nvSpPr>
-          <p:cNvPr id="17" name="Shape 15"/>
-          <p:cNvSpPr/>
-          <p:nvPr/>
-        </p:nvSpPr>
-        <p:spPr>
-          <a:xfrm>
-            <a:off x="4846320" y="4551106"/>
-            <a:ext cx="411480" cy="757494"/>
-          </a:xfrm>
-          <a:prstGeom prst="rect">
-            <a:avLst/>
-          </a:prstGeom>
-          <a:solidFill>
-            <a:srgbClr val="76B900">
-              <a:alpha val="30000"/>
-            </a:srgbClr>
-          </a:solidFill>
-          <a:ln w="16510">
-            <a:solidFill>
-              <a:srgbClr val="76B900"/>
-            </a:solidFill>
-            <a:prstDash val="solid"/>
-          </a:ln>
-        </p:spPr>
-      </p:sp>
-      <p:sp>
-        <p:nvSpPr>
-          <p:cNvPr id="18" name="Shape 16"/>
-          <p:cNvSpPr/>
-          <p:nvPr/>
-        </p:nvSpPr>
-        <p:spPr>
-          <a:xfrm>
-            <a:off x="5349240" y="2739938"/>
-            <a:ext cx="411480" cy="2568662"/>
-          </a:xfrm>
-          <a:prstGeom prst="rect">
-            <a:avLst/>
-          </a:prstGeom>
-          <a:solidFill>
-            <a:srgbClr val="FFB454">
-              <a:alpha val="30000"/>
-            </a:srgbClr>
-          </a:solidFill>
-          <a:ln w="16510">
-            <a:solidFill>
-              <a:srgbClr val="FFB454"/>
-            </a:solidFill>
-            <a:prstDash val="solid"/>
-          </a:ln>
-        </p:spPr>
-      </p:sp>
-      <p:sp>
-        <p:nvSpPr>
-          <p:cNvPr id="19" name="Text 17"/>
-          <p:cNvSpPr/>
-          <p:nvPr/>
-        </p:nvSpPr>
-        <p:spPr>
-          <a:xfrm>
-            <a:off x="4800600" y="5431536"/>
-            <a:ext cx="1005840" cy="182880"/>
+            <a:off x="4254500" y="5431536"/>
+            <a:ext cx="1524000" cy="182880"/>
           </a:xfrm>
           <a:prstGeom prst="rect">
             <a:avLst/>
@@ -4558,7 +4436,7 @@
                   <a:srgbClr val="F4F7FA"/>
                 </a:solidFill>
               </a:rPr>
-              <a:t>Two GPUs took 2.64–3.39× longer</a:t>
+              <a:t>Two GPUs took 2.65–3.58× longer</a:t>
             </a:r>
             <a:endParaRPr lang="en-US" sz="1250" dirty="0"/>
           </a:p>
@@ -4730,7 +4608,7 @@
                   <a:srgbClr val="76B900"/>
                 </a:solidFill>
               </a:rPr>
-              <a:t>14.7–19.0%</a:t>
+              <a:t>14.0–18.8%</a:t>
             </a:r>
             <a:endParaRPr lang="en-US" sz="2400" dirty="0">
               <a:solidFill>
@@ -4810,7 +4688,7 @@
                   <a:srgbClr val="FFB454"/>
                 </a:solidFill>
               </a:rPr>
-              <a:t>5.27–6.78×</a:t>
+              <a:t>5.31–7.16×</a:t>
             </a:r>
             <a:endParaRPr lang="en-US" sz="2000" dirty="0">
               <a:solidFill>
@@ -4910,7 +4788,7 @@
                   <a:srgbClr val="FFB454"/>
                 </a:solidFill>
               </a:rPr>
-              <a:t>WHY TWO GPUs LOST</a:t>
+              <a:t>TWO-GPU TRADEOFF</a:t>
             </a:r>
             <a:endParaRPr lang="en-US" sz="850" dirty="0"/>
           </a:p>
@@ -4963,7 +4841,7 @@
                   <a:srgbClr val="C7D0D9"/>
                 </a:solidFill>
               </a:rPr>
-              <a:t>This CNN is too small to offset those costs</a:t>
+              <a:t>More images add steps; per-GPU batch stays 32</a:t>
             </a:r>
           </a:p>
           <a:p>
@@ -5035,7 +4913,7 @@
           <p:cNvPr id="44" name="TextBox 43">
             <a:extLst>
               <a:ext uri="{FF2B5EF4-FFF2-40B4-BE49-F238E27FC236}">
-                <a16:creationId xmlns:a16="http://schemas.microsoft.com/office/drawing/2014/main" id="{6F880FAC-C191-B548-78C6-C5191CD2C359}"/>
+                <a16:creationId xmlns:a16="http://schemas.microsoft.com/office/drawing/2014/main" id="{32E537C1-B1C1-3159-B01A-825A02F82745}"/>
               </a:ext>
             </a:extLst>
           </p:cNvPr>
@@ -5044,7 +4922,7 @@
         </p:nvSpPr>
         <p:spPr>
           <a:xfrm>
-            <a:off x="1701800" y="4207672"/>
+            <a:off x="2159000" y="4181621"/>
             <a:ext cx="660400" cy="276999"/>
           </a:xfrm>
           <a:prstGeom prst="rect">
@@ -5066,7 +4944,7 @@
                 </a:solidFill>
                 <a:latin typeface="Aptos" panose="020B0004020202020204" pitchFamily="34" charset="0"/>
               </a:rPr>
-              <a:t>6.06</a:t>
+              <a:t>62.49</a:t>
             </a:r>
           </a:p>
         </p:txBody>
@@ -5076,7 +4954,7 @@
           <p:cNvPr id="45" name="TextBox 44">
             <a:extLst>
               <a:ext uri="{FF2B5EF4-FFF2-40B4-BE49-F238E27FC236}">
-                <a16:creationId xmlns:a16="http://schemas.microsoft.com/office/drawing/2014/main" id="{7813ACE8-125A-E031-3954-923CA1EE816A}"/>
+                <a16:creationId xmlns:a16="http://schemas.microsoft.com/office/drawing/2014/main" id="{72ED4E8F-704A-0FA5-C72E-A9818856E34A}"/>
               </a:ext>
             </a:extLst>
           </p:cNvPr>
@@ -5085,7 +4963,7 @@
         </p:nvSpPr>
         <p:spPr>
           <a:xfrm>
-            <a:off x="2204720" y="2821040"/>
+            <a:off x="2730500" y="2738612"/>
             <a:ext cx="660400" cy="276999"/>
           </a:xfrm>
           <a:prstGeom prst="rect">
@@ -5107,7 +4985,7 @@
                 </a:solidFill>
                 <a:latin typeface="Aptos" panose="020B0004020202020204" pitchFamily="34" charset="0"/>
               </a:rPr>
-              <a:t>15.99</a:t>
+              <a:t>165.78</a:t>
             </a:r>
           </a:p>
         </p:txBody>
@@ -5117,7 +4995,7 @@
           <p:cNvPr id="46" name="TextBox 45">
             <a:extLst>
               <a:ext uri="{FF2B5EF4-FFF2-40B4-BE49-F238E27FC236}">
-                <a16:creationId xmlns:a16="http://schemas.microsoft.com/office/drawing/2014/main" id="{F6768962-106E-E389-718E-566B885225E7}"/>
+                <a16:creationId xmlns:a16="http://schemas.microsoft.com/office/drawing/2014/main" id="{65BE3236-F9DA-BE1F-3293-05C450909434}"/>
               </a:ext>
             </a:extLst>
           </p:cNvPr>
@@ -5126,7 +5004,7 @@
         </p:nvSpPr>
         <p:spPr>
           <a:xfrm>
-            <a:off x="3210560" y="4169114"/>
+            <a:off x="4254500" y="4344933"/>
             <a:ext cx="660400" cy="276999"/>
           </a:xfrm>
           <a:prstGeom prst="rect">
@@ -5148,7 +5026,7 @@
                 </a:solidFill>
                 <a:latin typeface="Aptos" panose="020B0004020202020204" pitchFamily="34" charset="0"/>
               </a:rPr>
-              <a:t>6.34</a:t>
+              <a:t>50.80</a:t>
             </a:r>
           </a:p>
         </p:txBody>
@@ -5158,7 +5036,7 @@
           <p:cNvPr id="47" name="TextBox 46">
             <a:extLst>
               <a:ext uri="{FF2B5EF4-FFF2-40B4-BE49-F238E27FC236}">
-                <a16:creationId xmlns:a16="http://schemas.microsoft.com/office/drawing/2014/main" id="{9ABA9FE2-ADDE-220E-B71A-0302F7D19067}"/>
+                <a16:creationId xmlns:a16="http://schemas.microsoft.com/office/drawing/2014/main" id="{20314333-E2D4-3E5D-6D2E-61D21A1EBA8B}"/>
               </a:ext>
             </a:extLst>
           </p:cNvPr>
@@ -5167,7 +5045,7 @@
         </p:nvSpPr>
         <p:spPr>
           <a:xfrm>
-            <a:off x="3713480" y="2634607"/>
+            <a:off x="4826000" y="2512467"/>
             <a:ext cx="660400" cy="276999"/>
           </a:xfrm>
           <a:prstGeom prst="rect">
@@ -5189,7 +5067,7 @@
                 </a:solidFill>
                 <a:latin typeface="Aptos" panose="020B0004020202020204" pitchFamily="34" charset="0"/>
               </a:rPr>
-              <a:t>17.32</a:t>
+              <a:t>181.97</a:t>
             </a:r>
           </a:p>
         </p:txBody>
@@ -5199,7 +5077,7 @@
           <p:cNvPr id="48" name="TextBox 47">
             <a:extLst>
               <a:ext uri="{FF2B5EF4-FFF2-40B4-BE49-F238E27FC236}">
-                <a16:creationId xmlns:a16="http://schemas.microsoft.com/office/drawing/2014/main" id="{258B79D9-BCF7-B8C7-A344-225683BBB233}"/>
+                <a16:creationId xmlns:a16="http://schemas.microsoft.com/office/drawing/2014/main" id="{85F1B1CF-D86C-0260-999F-25A3D533718D}"/>
               </a:ext>
             </a:extLst>
           </p:cNvPr>
@@ -5208,8 +5086,8 @@
         </p:nvSpPr>
         <p:spPr>
           <a:xfrm>
-            <a:off x="4719320" y="4297106"/>
-            <a:ext cx="660400" cy="276999"/>
+            <a:off x="850900" y="5219700"/>
+            <a:ext cx="228600" cy="276999"/>
           </a:xfrm>
           <a:prstGeom prst="rect">
             <a:avLst/>
@@ -5222,15 +5100,14 @@
           </a:bodyPr>
           <a:lstStyle/>
           <a:p>
-            <a:pPr algn="ctr"/>
-            <a:r>
-              <a:rPr lang="en-US" sz="1100">
-                <a:solidFill>
-                  <a:srgbClr val="F4F7FA"/>
+            <a:r>
+              <a:rPr lang="en-US" sz="950">
+                <a:solidFill>
+                  <a:srgbClr val="C7D0D9"/>
                 </a:solidFill>
                 <a:latin typeface="Aptos" panose="020B0004020202020204" pitchFamily="34" charset="0"/>
               </a:rPr>
-              <a:t>5.42</a:t>
+              <a:t>0</a:t>
             </a:r>
           </a:p>
         </p:txBody>
@@ -5240,7 +5117,7 @@
           <p:cNvPr id="49" name="TextBox 48">
             <a:extLst>
               <a:ext uri="{FF2B5EF4-FFF2-40B4-BE49-F238E27FC236}">
-                <a16:creationId xmlns:a16="http://schemas.microsoft.com/office/drawing/2014/main" id="{0FB20FB0-B9A9-EFA7-A016-BF87FBE2F1A5}"/>
+                <a16:creationId xmlns:a16="http://schemas.microsoft.com/office/drawing/2014/main" id="{A83A0837-44F6-7853-FF47-0ADF34F4F62C}"/>
               </a:ext>
             </a:extLst>
           </p:cNvPr>
@@ -5249,8 +5126,8 @@
         </p:nvSpPr>
         <p:spPr>
           <a:xfrm>
-            <a:off x="5222240" y="2485938"/>
-            <a:ext cx="660400" cy="276999"/>
+            <a:off x="850900" y="4521200"/>
+            <a:ext cx="228600" cy="276999"/>
           </a:xfrm>
           <a:prstGeom prst="rect">
             <a:avLst/>
@@ -5263,15 +5140,14 @@
           </a:bodyPr>
           <a:lstStyle/>
           <a:p>
-            <a:pPr algn="ctr"/>
-            <a:r>
-              <a:rPr lang="en-US" sz="1100">
-                <a:solidFill>
-                  <a:srgbClr val="F4F7FA"/>
+            <a:r>
+              <a:rPr lang="en-US" sz="950">
+                <a:solidFill>
+                  <a:srgbClr val="C7D0D9"/>
                 </a:solidFill>
                 <a:latin typeface="Aptos" panose="020B0004020202020204" pitchFamily="34" charset="0"/>
               </a:rPr>
-              <a:t>18.39</a:t>
+              <a:t>50</a:t>
             </a:r>
           </a:p>
         </p:txBody>
@@ -5281,7 +5157,7 @@
           <p:cNvPr id="50" name="TextBox 49">
             <a:extLst>
               <a:ext uri="{FF2B5EF4-FFF2-40B4-BE49-F238E27FC236}">
-                <a16:creationId xmlns:a16="http://schemas.microsoft.com/office/drawing/2014/main" id="{A3C400A0-3A34-5770-BBF6-A89581371484}"/>
+                <a16:creationId xmlns:a16="http://schemas.microsoft.com/office/drawing/2014/main" id="{E654BEDE-5DDB-9A86-E4A4-C9B0D4DA6D95}"/>
               </a:ext>
             </a:extLst>
           </p:cNvPr>
@@ -5290,7 +5166,7 @@
         </p:nvSpPr>
         <p:spPr>
           <a:xfrm>
-            <a:off x="850900" y="5219700"/>
+            <a:off x="850900" y="3822700"/>
             <a:ext cx="228600" cy="276999"/>
           </a:xfrm>
           <a:prstGeom prst="rect">
@@ -5311,7 +5187,7 @@
                 </a:solidFill>
                 <a:latin typeface="Aptos" panose="020B0004020202020204" pitchFamily="34" charset="0"/>
               </a:rPr>
-              <a:t>0</a:t>
+              <a:t>100</a:t>
             </a:r>
           </a:p>
         </p:txBody>
@@ -5321,7 +5197,7 @@
           <p:cNvPr id="51" name="TextBox 50">
             <a:extLst>
               <a:ext uri="{FF2B5EF4-FFF2-40B4-BE49-F238E27FC236}">
-                <a16:creationId xmlns:a16="http://schemas.microsoft.com/office/drawing/2014/main" id="{51A85870-1E1D-2173-5681-54F9F3268171}"/>
+                <a16:creationId xmlns:a16="http://schemas.microsoft.com/office/drawing/2014/main" id="{8ABBF999-DC3A-C8E5-391B-1E77F27CAE07}"/>
               </a:ext>
             </a:extLst>
           </p:cNvPr>
@@ -5330,7 +5206,7 @@
         </p:nvSpPr>
         <p:spPr>
           <a:xfrm>
-            <a:off x="850900" y="4521200"/>
+            <a:off x="850900" y="3124200"/>
             <a:ext cx="228600" cy="276999"/>
           </a:xfrm>
           <a:prstGeom prst="rect">
@@ -5351,7 +5227,7 @@
                 </a:solidFill>
                 <a:latin typeface="Aptos" panose="020B0004020202020204" pitchFamily="34" charset="0"/>
               </a:rPr>
-              <a:t>5</a:t>
+              <a:t>150</a:t>
             </a:r>
           </a:p>
         </p:txBody>
@@ -5361,7 +5237,7 @@
           <p:cNvPr id="52" name="TextBox 51">
             <a:extLst>
               <a:ext uri="{FF2B5EF4-FFF2-40B4-BE49-F238E27FC236}">
-                <a16:creationId xmlns:a16="http://schemas.microsoft.com/office/drawing/2014/main" id="{85186F6E-629F-ADD6-4484-1FF5856EF962}"/>
+                <a16:creationId xmlns:a16="http://schemas.microsoft.com/office/drawing/2014/main" id="{CFD66717-EC2E-5477-18F0-64D6BAB518F1}"/>
               </a:ext>
             </a:extLst>
           </p:cNvPr>
@@ -5370,86 +5246,6 @@
         </p:nvSpPr>
         <p:spPr>
           <a:xfrm>
-            <a:off x="850900" y="3822700"/>
-            <a:ext cx="228600" cy="276999"/>
-          </a:xfrm>
-          <a:prstGeom prst="rect">
-            <a:avLst/>
-          </a:prstGeom>
-          <a:noFill/>
-        </p:spPr>
-        <p:txBody>
-          <a:bodyPr vert="horz" lIns="0" tIns="0" rIns="0" bIns="0" rtlCol="0">
-            <a:noAutofit/>
-          </a:bodyPr>
-          <a:lstStyle/>
-          <a:p>
-            <a:r>
-              <a:rPr lang="en-US" sz="950">
-                <a:solidFill>
-                  <a:srgbClr val="C7D0D9"/>
-                </a:solidFill>
-                <a:latin typeface="Aptos" panose="020B0004020202020204" pitchFamily="34" charset="0"/>
-              </a:rPr>
-              <a:t>10</a:t>
-            </a:r>
-          </a:p>
-        </p:txBody>
-      </p:sp>
-      <p:sp>
-        <p:nvSpPr>
-          <p:cNvPr id="53" name="TextBox 52">
-            <a:extLst>
-              <a:ext uri="{FF2B5EF4-FFF2-40B4-BE49-F238E27FC236}">
-                <a16:creationId xmlns:a16="http://schemas.microsoft.com/office/drawing/2014/main" id="{1DA7878D-77EA-6800-861F-238DDFF7F6AD}"/>
-              </a:ext>
-            </a:extLst>
-          </p:cNvPr>
-          <p:cNvSpPr txBox="1"/>
-          <p:nvPr/>
-        </p:nvSpPr>
-        <p:spPr>
-          <a:xfrm>
-            <a:off x="850900" y="3124200"/>
-            <a:ext cx="228600" cy="276999"/>
-          </a:xfrm>
-          <a:prstGeom prst="rect">
-            <a:avLst/>
-          </a:prstGeom>
-          <a:noFill/>
-        </p:spPr>
-        <p:txBody>
-          <a:bodyPr vert="horz" lIns="0" tIns="0" rIns="0" bIns="0" rtlCol="0">
-            <a:noAutofit/>
-          </a:bodyPr>
-          <a:lstStyle/>
-          <a:p>
-            <a:r>
-              <a:rPr lang="en-US" sz="950">
-                <a:solidFill>
-                  <a:srgbClr val="C7D0D9"/>
-                </a:solidFill>
-                <a:latin typeface="Aptos" panose="020B0004020202020204" pitchFamily="34" charset="0"/>
-              </a:rPr>
-              <a:t>15</a:t>
-            </a:r>
-          </a:p>
-        </p:txBody>
-      </p:sp>
-      <p:sp>
-        <p:nvSpPr>
-          <p:cNvPr id="54" name="TextBox 53">
-            <a:extLst>
-              <a:ext uri="{FF2B5EF4-FFF2-40B4-BE49-F238E27FC236}">
-                <a16:creationId xmlns:a16="http://schemas.microsoft.com/office/drawing/2014/main" id="{1366CA91-B7D0-F4C2-B88F-798FF0FB5680}"/>
-              </a:ext>
-            </a:extLst>
-          </p:cNvPr>
-          <p:cNvSpPr txBox="1"/>
-          <p:nvPr/>
-        </p:nvSpPr>
-        <p:spPr>
-          <a:xfrm>
             <a:off x="850900" y="2425700"/>
             <a:ext cx="228600" cy="276999"/>
           </a:xfrm>
@@ -5471,7 +5267,7 @@
                 </a:solidFill>
                 <a:latin typeface="Aptos" panose="020B0004020202020204" pitchFamily="34" charset="0"/>
               </a:rPr>
-              <a:t>20</a:t>
+              <a:t>200</a:t>
             </a:r>
           </a:p>
         </p:txBody>
@@ -5571,7 +5367,7 @@
                   <a:srgbClr val="7E8A97"/>
                 </a:solidFill>
               </a:rPr>
-              <a:t>All seven final models classified 956 of 1,000 test digits correctly. All 170 correctness checks passed.</a:t>
+              <a:t>Five final models evaluated on all 10,000 official test digits. All 119 numerical checks passed.</a:t>
             </a:r>
             <a:endParaRPr lang="en-US" sz="1150" dirty="0"/>
           </a:p>
@@ -5774,7 +5570,7 @@
                   <a:srgbClr val="F4F7FA"/>
                 </a:solidFill>
               </a:rPr>
-              <a:t>95.6%</a:t>
+              <a:t>97.13%</a:t>
             </a:r>
             <a:endParaRPr lang="en-US" sz="2000" dirty="0"/>
           </a:p>
@@ -5881,7 +5677,7 @@
                   <a:srgbClr val="F4F7FA"/>
                 </a:solidFill>
               </a:rPr>
-              <a:t>95.6%</a:t>
+              <a:t>97.17%</a:t>
             </a:r>
             <a:endParaRPr lang="en-US" sz="2000" dirty="0"/>
           </a:p>
@@ -5988,7 +5784,7 @@
                   <a:srgbClr val="F4F7FA"/>
                 </a:solidFill>
               </a:rPr>
-              <a:t>95.6%</a:t>
+              <a:t>97.15–97.17%</a:t>
             </a:r>
             <a:endParaRPr lang="en-US" sz="2000" dirty="0"/>
           </a:p>
@@ -6290,7 +6086,7 @@
         <p:spPr>
           <a:xfrm>
             <a:off x="2121408" y="4544568"/>
-            <a:ext cx="320040" cy="274320"/>
+            <a:ext cx="320040" cy="393700"/>
           </a:xfrm>
           <a:prstGeom prst="rect">
             <a:avLst/>
@@ -6366,7 +6162,7 @@
         <p:spPr>
           <a:xfrm>
             <a:off x="3520440" y="4544568"/>
-            <a:ext cx="320040" cy="274320"/>
+            <a:ext cx="320040" cy="393700"/>
           </a:xfrm>
           <a:prstGeom prst="rect">
             <a:avLst/>
@@ -6465,7 +6261,7 @@
                   <a:srgbClr val="C7D0D9"/>
                 </a:solidFill>
               </a:rPr>
-              <a:t>170 checks passed: forward and input/weight/bias gradients, including non-square inputs and partial tiles.</a:t>
+              <a:t>119 checks passed: forward and input/weight/bias gradients, including non-square inputs, multiple channels and batches.</a:t>
             </a:r>
             <a:endParaRPr lang="en-US" sz="1140" dirty="0"/>
           </a:p>
@@ -6600,7 +6396,7 @@
                   <a:srgbClr val="C7D0D9"/>
                 </a:solidFill>
               </a:rPr>
-              <a:t>Every final model: 956/1,000 correct</a:t>
+              <a:t>Full test accuracy: 97.13–97.17%</a:t>
             </a:r>
           </a:p>
           <a:p>
@@ -6614,7 +6410,7 @@
                   <a:srgbClr val="C7D0D9"/>
                 </a:solidFill>
               </a:rPr>
-              <a:t>Same data, initialization and precision</a:t>
+              <a:t>Same splits, initialization and precision</a:t>
             </a:r>
           </a:p>
           <a:p>
@@ -6680,7 +6476,7 @@
                   <a:srgbClr val="A3E635"/>
                 </a:solidFill>
               </a:rPr>
-              <a:t>Same accuracy; lower wall time on one GPU.</a:t>
+              <a:t>Valid kernels, with separately trained final models.</a:t>
             </a:r>
             <a:endParaRPr lang="en-US" sz="1220" dirty="0"/>
           </a:p>
@@ -6828,7 +6624,7 @@
                   <a:srgbClr val="7E8A97"/>
                 </a:solidFill>
               </a:rPr>
-              <a:t>Choose hardware by workload: CPU for small requests, one GPU for batches, more GPUs only when scaling pays.</a:t>
+              <a:t>Full MNIST, same CNN and setup. Compare request latency, training time and batched throughput separately.</a:t>
             </a:r>
             <a:endParaRPr lang="en-US" sz="1150" dirty="0"/>
           </a:p>
@@ -7191,7 +6987,7 @@
                   <a:srgbClr val="76B900"/>
                 </a:solidFill>
               </a:rPr>
-              <a:t>CPU wins tiny-request latency</a:t>
+              <a:t>PyTorch CPU wins digit latency</a:t>
             </a:r>
             <a:endParaRPr lang="en-US" sz="1550" dirty="0"/>
           </a:p>
@@ -7229,7 +7025,7 @@
                   <a:srgbClr val="C7D0D9"/>
                 </a:solidFill>
               </a:rPr>
-              <a:t>83.45 µs per digit in this run. Framework and launch overhead matter.</a:t>
+              <a:t>88.96 µs per digit in this run. Framework and launch overhead matter.</a:t>
             </a:r>
             <a:endParaRPr lang="en-US" sz="1250" dirty="0"/>
           </a:p>
@@ -7357,7 +7153,7 @@
                   <a:srgbClr val="A78BFA"/>
                 </a:solidFill>
               </a:rPr>
-              <a:t>One GPU wins this training run</a:t>
+              <a:t>PyTorch wins training time</a:t>
             </a:r>
             <a:endParaRPr lang="en-US" sz="1550" dirty="0"/>
           </a:p>
@@ -7395,7 +7191,7 @@
                   <a:srgbClr val="C7D0D9"/>
                 </a:solidFill>
               </a:rPr>
-              <a:t>PyTorch/T4: 5.42 s for 50 epochs vs CPU 10.17 s. All models: 95.6% test accuracy.</a:t>
+              <a:t>50.80 s for 50 epochs vs CPU 94.59 s. Full test accuracy: 97.13–97.17%.</a:t>
             </a:r>
             <a:endParaRPr lang="en-US" sz="1250" dirty="0"/>
           </a:p>
@@ -7561,7 +7357,7 @@
                   <a:srgbClr val="C7D0D9"/>
                 </a:solidFill>
               </a:rPr>
-              <a:t>DataParallel: 15.99–18.39 s. Communication outweighed the saved compute time.</a:t>
+              <a:t>DataParallel: 165.78–181.97 s. More devices add replication and communication costs.</a:t>
             </a:r>
             <a:endParaRPr lang="en-US" sz="1250" dirty="0"/>
           </a:p>
@@ -7664,7 +7460,7 @@
                   <a:srgbClr val="F4F7FA"/>
                 </a:solidFill>
               </a:rPr>
-              <a:t>CPU for tiny requests → one GPU for batched work → two GPUs only when synchronization pays.</a:t>
+              <a:t>Choose by latency and throughput. Add GPUs when saved compute time exceeds coordination.</a:t>
             </a:r>
             <a:endParaRPr lang="en-US" sz="1320" dirty="0"/>
           </a:p>
@@ -7702,7 +7498,7 @@
                   <a:srgbClr val="7E8A97"/>
                 </a:solidFill>
               </a:rPr>
-              <a:t>Demo: seven checkpoints → the same held-out digits → predictions and true labels.</a:t>
+              <a:t>Demo: five checkpoints → the same held-out digits → predictions and true labels.</a:t>
             </a:r>
             <a:endParaRPr lang="en-US" sz="1050" dirty="0"/>
           </a:p>
@@ -7850,7 +7646,7 @@
                   <a:srgbClr val="7E8A97"/>
                 </a:solidFill>
               </a:rPr>
-              <a:t>Our digit classifier: 28×28 image → convolution → ReLU/pool → 676 features → ten class scores.</a:t>
+              <a:t>Digit classifier: 28×28 image → convolution → ReLU/pool → 676 features → ten class scores.</a:t>
             </a:r>
             <a:endParaRPr lang="en-US" sz="1150" dirty="0"/>
           </a:p>
@@ -9729,7 +9525,7 @@
         <p:spPr>
           <a:xfrm>
             <a:off x="8339328" y="2395728"/>
-            <a:ext cx="1005840" cy="164592"/>
+            <a:ext cx="1005840" cy="241300"/>
           </a:xfrm>
           <a:prstGeom prst="rect">
             <a:avLst/>
@@ -11233,7 +11029,7 @@
         <p:spPr>
           <a:xfrm>
             <a:off x="6382512" y="1947672"/>
-            <a:ext cx="4572000" cy="329184"/>
+            <a:ext cx="4572000" cy="508000"/>
           </a:xfrm>
           <a:prstGeom prst="rect">
             <a:avLst/>
@@ -12553,7 +12349,7 @@
         <p:spPr>
           <a:xfrm>
             <a:off x="1060704" y="2130552"/>
-            <a:ext cx="640080" cy="228600"/>
+            <a:ext cx="640080" cy="304800"/>
           </a:xfrm>
           <a:prstGeom prst="rect">
             <a:avLst/>
@@ -13559,7 +13355,7 @@
                   <a:srgbClr val="41D9FF"/>
                 </a:solidFill>
               </a:rPr>
-              <a:t>CPU: low request latency</a:t>
+              <a:t>OpenMP batch 64: 3.00×</a:t>
             </a:r>
             <a:endParaRPr lang="en-US" sz="1600" dirty="0"/>
           </a:p>
@@ -13597,7 +13393,7 @@
                   <a:srgbClr val="A3E635"/>
                 </a:solidFill>
               </a:rPr>
-              <a:t>GPU: high batch throughput</a:t>
+              <a:t>Native CPU benchmark: four threads</a:t>
             </a:r>
             <a:endParaRPr lang="en-US" sz="1540" dirty="0"/>
           </a:p>
@@ -14302,7 +14098,7 @@
         <p:spPr>
           <a:xfrm>
             <a:off x="3703320" y="1956816"/>
-            <a:ext cx="2880360" cy="310896"/>
+            <a:ext cx="2880360" cy="508000"/>
           </a:xfrm>
           <a:prstGeom prst="rect">
             <a:avLst/>
@@ -18981,7 +18777,7 @@
                   <a:srgbClr val="F4F7FA"/>
                 </a:solidFill>
               </a:rPr>
-              <a:t>One output per thread; 256 threads per block.</a:t>
+              <a:t>Libraries choose the thread/block mapping.</a:t>
             </a:r>
             <a:endParaRPr lang="en-US" sz="1350" dirty="0"/>
           </a:p>
@@ -19372,7 +19168,7 @@
                   <a:srgbClr val="A3E635"/>
                 </a:solidFill>
               </a:rPr>
-              <a:t>CUDA exposes concurrent work; shared-memory reuse is an optimization to test.</a:t>
+              <a:t>cuDNN maps convolution onto CUDA kernels with concurrent work and data reuse.</a:t>
             </a:r>
             <a:endParaRPr lang="en-US" sz="1450" dirty="0"/>
           </a:p>
@@ -20181,7 +19977,7 @@
                   <a:srgbClr val="7E8A97"/>
                 </a:solidFill>
               </a:rPr>
-              <a:t>Same model, data, loss and SGD. Custom kernels replace convolution forward and backward.</a:t>
+              <a:t>Same CNN, data, loss and SGD. Convolution runs through CPU PyTorch, direct cuDNN or GPU PyTorch.</a:t>
             </a:r>
             <a:endParaRPr lang="en-US" sz="1160" dirty="0"/>
           </a:p>
@@ -20272,12 +20068,12 @@
               <a:buNone/>
             </a:pPr>
             <a:r>
-              <a:rPr lang="en-US" sz="850" b="1" kern="0" spc="100" dirty="0">
+              <a:rPr lang="en-US" sz="850" b="1" kern="0" spc="100">
                 <a:solidFill>
                   <a:srgbClr val="76B900"/>
                 </a:solidFill>
               </a:rPr>
-              <a:t>CONV KERNEL MAPPING</a:t>
+              <a:t>LIBRARY KERNEL DESIGN</a:t>
             </a:r>
             <a:endParaRPr lang="en-US" sz="850" dirty="0"/>
           </a:p>
@@ -20315,7 +20111,7 @@
                   <a:srgbClr val="F4F7FA"/>
                 </a:solidFill>
               </a:rPr>
-              <a:t>Forward convolution</a:t>
+              <a:t>cuDNN implicit GEMM</a:t>
             </a:r>
             <a:endParaRPr lang="en-US" sz="1550" dirty="0"/>
           </a:p>
@@ -20354,7 +20150,7 @@
                   <a:srgbClr val="C7D0D9"/>
                 </a:solidFill>
               </a:rPr>
-              <a:t>Thread → one output; 256 threads/block</a:t>
+              <a:t>43,264 image patches × 9 values per patch</a:t>
             </a:r>
           </a:p>
           <a:p>
@@ -20368,7 +20164,7 @@
                   <a:srgbClr val="C7D0D9"/>
                 </a:solidFill>
               </a:rPr>
-              <a:t>Each output sums nine products plus bias</a:t>
+              <a:t>9×4 filter matrix → 43,264×4 output matrix</a:t>
             </a:r>
           </a:p>
           <a:p>
@@ -20382,7 +20178,7 @@
                   <a:srgbClr val="C7D0D9"/>
                 </a:solidFill>
               </a:rPr>
-              <a:t>Tiled variant → 16×16 outputs reuse 18×18 input</a:t>
+              <a:t>cuDNN computes implicit GEMM on CUDA</a:t>
             </a:r>
             <a:endParaRPr lang="en-US" sz="1380" dirty="0"/>
           </a:p>
@@ -20396,8 +20192,8 @@
         </p:nvSpPr>
         <p:spPr>
           <a:xfrm>
-            <a:off x="868680" y="5788152"/>
-            <a:ext cx="4297680" cy="256032"/>
+            <a:off x="868680" y="5638800"/>
+            <a:ext cx="4297680" cy="508000"/>
           </a:xfrm>
           <a:prstGeom prst="rect">
             <a:avLst/>
@@ -20420,7 +20216,7 @@
                   <a:srgbClr val="A3E635"/>
                 </a:solidFill>
               </a:rPr>
-              <a:t>Backward: block reductions sum the weight gradients.</a:t>
+              <a:t>Library kernels compute gradients; DataParallel sums replica contributions.</a:t>
             </a:r>
             <a:endParaRPr lang="en-US" sz="1250" dirty="0"/>
           </a:p>
@@ -20913,7 +20709,7 @@
                   <a:srgbClr val="F4F7FA"/>
                 </a:solidFill>
               </a:rPr>
-              <a:t>Custom CUDA convolution</a:t>
+              <a:t>Memory and kernel launches</a:t>
             </a:r>
             <a:endParaRPr lang="en-US" sz="1070" dirty="0"/>
           </a:p>
@@ -20951,7 +20747,7 @@
                   <a:srgbClr val="7E8A97"/>
                 </a:solidFill>
               </a:rPr>
-              <a:t>thread control</a:t>
+              <a:t>execution layer</a:t>
             </a:r>
             <a:endParaRPr lang="en-US" sz="970" dirty="0"/>
           </a:p>
@@ -22497,7 +22293,7 @@
                   <a:srgbClr val="7E8A97"/>
                 </a:solidFill>
               </a:rPr>
-              <a:t>50 epochs · 4,800 train / 1,200 validation / 1,000 test · identical model, weights and batch 64.</a:t>
+              <a:t>50 epochs · 48,000 train / 12,000 validation / 10,000 test · same CNN, initialization and batch 64.</a:t>
             </a:r>
             <a:endParaRPr lang="en-US" sz="1150" dirty="0"/>
           </a:p>
@@ -22696,7 +22492,7 @@
                   <a:srgbClr val="F4F7FA"/>
                 </a:solidFill>
               </a:rPr>
-              <a:t>5.42 s</a:t>
+              <a:t>50.80 s</a:t>
             </a:r>
             <a:endParaRPr lang="en-US" sz="3600" dirty="0"/>
           </a:p>
@@ -22747,7 +22543,7 @@
                   <a:srgbClr val="7E8A97"/>
                 </a:solidFill>
               </a:rPr>
-              <a:t>1.88× faster than CPU</a:t>
+              <a:t>1.86× vs CPU</a:t>
             </a:r>
             <a:endParaRPr lang="en-US" sz="1100" dirty="0"/>
           </a:p>
@@ -22823,7 +22619,7 @@
                   <a:srgbClr val="C7D0D9"/>
                 </a:solidFill>
               </a:rPr>
-              <a:t>CPU: 83.45 µs per digit.</a:t>
+              <a:t>PyTorch CPU: 88.96 µs per digit.</a:t>
             </a:r>
           </a:p>
           <a:p>
@@ -22836,7 +22632,7 @@
                   <a:srgbClr val="C7D0D9"/>
                 </a:solidFill>
               </a:rPr>
-              <a:t>CUDA: 178,698 batch img/s.</a:t>
+              <a:t>PyTorch: 180,668 batch img/s.</a:t>
             </a:r>
           </a:p>
           <a:p>
@@ -22849,7 +22645,7 @@
                   <a:srgbClr val="C7D0D9"/>
                 </a:solidFill>
               </a:rPr>
-              <a:t>The best path depends on how much work is submitted.</a:t>
+              <a:t>Choose by workload size.</a:t>
             </a:r>
             <a:endParaRPr lang="en-US" sz="1170" dirty="0"/>
           </a:p>
@@ -22958,7 +22754,7 @@
           <p:cNvPr id="43" name="Table 42">
             <a:extLst>
               <a:ext uri="{FF2B5EF4-FFF2-40B4-BE49-F238E27FC236}">
-                <a16:creationId xmlns:a16="http://schemas.microsoft.com/office/drawing/2014/main" id="{A866BF4B-8C4A-9E28-866F-8959B997A68E}"/>
+                <a16:creationId xmlns:a16="http://schemas.microsoft.com/office/drawing/2014/main" id="{D32F8CF6-66A7-D6A7-65C9-9CD8C82CA7BA}"/>
               </a:ext>
             </a:extLst>
           </p:cNvPr>
@@ -22968,14 +22764,14 @@
           <p:nvPr>
             <p:extLst>
               <p:ext uri="{D42A27DB-BD31-4B8C-83A1-F6EECF244321}">
-                <p14:modId xmlns:p14="http://schemas.microsoft.com/office/powerpoint/2010/main" val="3130483589"/>
+                <p14:modId xmlns:p14="http://schemas.microsoft.com/office/powerpoint/2010/main" val="671858407"/>
               </p:ext>
             </p:extLst>
           </p:nvPr>
         </p:nvGraphicFramePr>
         <p:xfrm>
-          <a:off x="863600" y="1676400"/>
-          <a:ext cx="7340600" cy="3556000"/>
+          <a:off x="863600" y="1879600"/>
+          <a:ext cx="7340600" cy="3124200"/>
         </p:xfrm>
         <a:graphic>
           <a:graphicData uri="http://schemas.openxmlformats.org/drawingml/2006/table">
@@ -22987,40 +22783,40 @@
                 <a:gridCol w="2870200">
                   <a:extLst>
                     <a:ext uri="{9D8B030D-6E8A-4147-A177-3AD203B41FA5}">
-                      <a16:colId xmlns:a16="http://schemas.microsoft.com/office/drawing/2014/main" val="436632136"/>
+                      <a16:colId xmlns:a16="http://schemas.microsoft.com/office/drawing/2014/main" val="3418121413"/>
                     </a:ext>
                   </a:extLst>
                 </a:gridCol>
                 <a:gridCol w="990600">
                   <a:extLst>
                     <a:ext uri="{9D8B030D-6E8A-4147-A177-3AD203B41FA5}">
-                      <a16:colId xmlns:a16="http://schemas.microsoft.com/office/drawing/2014/main" val="277174764"/>
+                      <a16:colId xmlns:a16="http://schemas.microsoft.com/office/drawing/2014/main" val="2410174412"/>
                     </a:ext>
                   </a:extLst>
                 </a:gridCol>
                 <a:gridCol w="990600">
                   <a:extLst>
                     <a:ext uri="{9D8B030D-6E8A-4147-A177-3AD203B41FA5}">
-                      <a16:colId xmlns:a16="http://schemas.microsoft.com/office/drawing/2014/main" val="1581319356"/>
+                      <a16:colId xmlns:a16="http://schemas.microsoft.com/office/drawing/2014/main" val="1241685515"/>
                     </a:ext>
                   </a:extLst>
                 </a:gridCol>
                 <a:gridCol w="990600">
                   <a:extLst>
                     <a:ext uri="{9D8B030D-6E8A-4147-A177-3AD203B41FA5}">
-                      <a16:colId xmlns:a16="http://schemas.microsoft.com/office/drawing/2014/main" val="4177114884"/>
+                      <a16:colId xmlns:a16="http://schemas.microsoft.com/office/drawing/2014/main" val="3826764011"/>
                     </a:ext>
                   </a:extLst>
                 </a:gridCol>
                 <a:gridCol w="1498600">
                   <a:extLst>
                     <a:ext uri="{9D8B030D-6E8A-4147-A177-3AD203B41FA5}">
-                      <a16:colId xmlns:a16="http://schemas.microsoft.com/office/drawing/2014/main" val="1796826327"/>
+                      <a16:colId xmlns:a16="http://schemas.microsoft.com/office/drawing/2014/main" val="3345259614"/>
                     </a:ext>
                   </a:extLst>
                 </a:gridCol>
               </a:tblGrid>
-              <a:tr h="444500">
+              <a:tr h="520700">
                 <a:tc>
                   <a:txBody>
                     <a:bodyPr/>
@@ -23268,11 +23064,11 @@
                 </a:tc>
                 <a:extLst>
                   <a:ext uri="{0D108BD9-81ED-4DB2-BD59-A6C34878D82A}">
-                    <a16:rowId xmlns:a16="http://schemas.microsoft.com/office/drawing/2014/main" val="745903867"/>
+                    <a16:rowId xmlns:a16="http://schemas.microsoft.com/office/drawing/2014/main" val="1327228823"/>
                   </a:ext>
                 </a:extLst>
               </a:tr>
-              <a:tr h="444500">
+              <a:tr h="520700">
                 <a:tc>
                   <a:txBody>
                     <a:bodyPr/>
@@ -23286,7 +23082,7 @@
                         <a:buNone/>
                       </a:pPr>
                       <a:r>
-                        <a:rPr lang="en-US" sz="1300" b="0">
+                        <a:rPr lang="en-US" sz="1400" b="0">
                           <a:solidFill>
                             <a:srgbClr val="41D9FF"/>
                           </a:solidFill>
@@ -23335,13 +23131,13 @@
                         <a:buNone/>
                       </a:pPr>
                       <a:r>
-                        <a:rPr lang="en-US" sz="1300" b="0">
+                        <a:rPr lang="en-US" sz="1400" b="0">
                           <a:solidFill>
                             <a:srgbClr val="F4F7FA"/>
                           </a:solidFill>
                           <a:latin typeface="Aptos" panose="020B0004020202020204" pitchFamily="34" charset="0"/>
                         </a:rPr>
-                        <a:t>10.17</a:t>
+                        <a:t>94.59</a:t>
                       </a:r>
                     </a:p>
                   </a:txBody>
@@ -23384,13 +23180,13 @@
                         <a:buNone/>
                       </a:pPr>
                       <a:r>
-                        <a:rPr lang="en-US" sz="1300" b="0">
+                        <a:rPr lang="en-US" sz="1400" b="0">
                           <a:solidFill>
                             <a:srgbClr val="F4F7FA"/>
                           </a:solidFill>
                           <a:latin typeface="Aptos" panose="020B0004020202020204" pitchFamily="34" charset="0"/>
                         </a:rPr>
-                        <a:t>23.80</a:t>
+                        <a:t>22.65</a:t>
                       </a:r>
                     </a:p>
                   </a:txBody>
@@ -23433,13 +23229,13 @@
                         <a:buNone/>
                       </a:pPr>
                       <a:r>
-                        <a:rPr lang="en-US" sz="1300" b="0">
+                        <a:rPr lang="en-US" sz="1400" b="0">
                           <a:solidFill>
                             <a:srgbClr val="F4F7FA"/>
                           </a:solidFill>
                           <a:latin typeface="Aptos" panose="020B0004020202020204" pitchFamily="34" charset="0"/>
                         </a:rPr>
-                        <a:t>83.45</a:t>
+                        <a:t>88.96</a:t>
                       </a:r>
                     </a:p>
                   </a:txBody>
@@ -23482,13 +23278,13 @@
                         <a:buNone/>
                       </a:pPr>
                       <a:r>
-                        <a:rPr lang="en-US" sz="1300" b="0">
+                        <a:rPr lang="en-US" sz="1400" b="0">
                           <a:solidFill>
                             <a:srgbClr val="F4F7FA"/>
                           </a:solidFill>
                           <a:latin typeface="Aptos" panose="020B0004020202020204" pitchFamily="34" charset="0"/>
                         </a:rPr>
-                        <a:t>59,454</a:t>
+                        <a:t>60,449</a:t>
                       </a:r>
                     </a:p>
                   </a:txBody>
@@ -23520,11 +23316,11 @@
                 </a:tc>
                 <a:extLst>
                   <a:ext uri="{0D108BD9-81ED-4DB2-BD59-A6C34878D82A}">
-                    <a16:rowId xmlns:a16="http://schemas.microsoft.com/office/drawing/2014/main" val="1194304263"/>
+                    <a16:rowId xmlns:a16="http://schemas.microsoft.com/office/drawing/2014/main" val="1174037687"/>
                   </a:ext>
                 </a:extLst>
               </a:tr>
-              <a:tr h="444500">
+              <a:tr h="520700">
                 <a:tc>
                   <a:txBody>
                     <a:bodyPr/>
@@ -23538,511 +23334,7 @@
                         <a:buNone/>
                       </a:pPr>
                       <a:r>
-                        <a:rPr lang="en-US" sz="1300" b="0">
-                          <a:solidFill>
-                            <a:srgbClr val="76B900"/>
-                          </a:solidFill>
-                          <a:latin typeface="Aptos" panose="020B0004020202020204" pitchFamily="34" charset="0"/>
-                        </a:rPr>
-                        <a:t>CUDA · 1 GPU</a:t>
-                      </a:r>
-                    </a:p>
-                  </a:txBody>
-                  <a:tcPr marL="88900" marR="63500" marT="50800" marB="50800">
-                    <a:lnL w="12700" cmpd="sng">
-                      <a:solidFill>
-                        <a:schemeClr val="lt1"/>
-                      </a:solidFill>
-                    </a:lnL>
-                    <a:lnR w="12700" cmpd="sng">
-                      <a:solidFill>
-                        <a:schemeClr val="lt1"/>
-                      </a:solidFill>
-                    </a:lnR>
-                    <a:lnT w="9525" cmpd="sng">
-                      <a:solidFill>
-                        <a:srgbClr val="24303C"/>
-                      </a:solidFill>
-                    </a:lnT>
-                    <a:lnB w="9525" cmpd="sng">
-                      <a:solidFill>
-                        <a:srgbClr val="24303C"/>
-                      </a:solidFill>
-                    </a:lnB>
-                    <a:solidFill>
-                      <a:srgbClr val="121923"/>
-                    </a:solidFill>
-                  </a:tcPr>
-                </a:tc>
-                <a:tc>
-                  <a:txBody>
-                    <a:bodyPr/>
-                    <a:lstStyle/>
-                    <a:p>
-                      <a:pPr>
-                        <a:spcAft>
-                          <a:spcPts val="0"/>
-                        </a:spcAft>
-                        <a:buFontTx/>
-                        <a:buNone/>
-                      </a:pPr>
-                      <a:r>
-                        <a:rPr lang="en-US" sz="1300" b="0">
-                          <a:solidFill>
-                            <a:srgbClr val="F4F7FA"/>
-                          </a:solidFill>
-                          <a:latin typeface="Aptos" panose="020B0004020202020204" pitchFamily="34" charset="0"/>
-                        </a:rPr>
-                        <a:t>6.06</a:t>
-                      </a:r>
-                    </a:p>
-                  </a:txBody>
-                  <a:tcPr marL="88900" marR="63500" marT="50800" marB="50800">
-                    <a:lnL w="12700" cmpd="sng">
-                      <a:solidFill>
-                        <a:schemeClr val="lt1"/>
-                      </a:solidFill>
-                    </a:lnL>
-                    <a:lnR w="12700" cmpd="sng">
-                      <a:solidFill>
-                        <a:schemeClr val="lt1"/>
-                      </a:solidFill>
-                    </a:lnR>
-                    <a:lnT w="9525" cmpd="sng">
-                      <a:solidFill>
-                        <a:srgbClr val="24303C"/>
-                      </a:solidFill>
-                    </a:lnT>
-                    <a:lnB w="9525" cmpd="sng">
-                      <a:solidFill>
-                        <a:srgbClr val="24303C"/>
-                      </a:solidFill>
-                    </a:lnB>
-                    <a:solidFill>
-                      <a:srgbClr val="121923"/>
-                    </a:solidFill>
-                  </a:tcPr>
-                </a:tc>
-                <a:tc>
-                  <a:txBody>
-                    <a:bodyPr/>
-                    <a:lstStyle/>
-                    <a:p>
-                      <a:pPr>
-                        <a:spcAft>
-                          <a:spcPts val="0"/>
-                        </a:spcAft>
-                        <a:buFontTx/>
-                        <a:buNone/>
-                      </a:pPr>
-                      <a:r>
-                        <a:rPr lang="en-US" sz="1300" b="0">
-                          <a:solidFill>
-                            <a:srgbClr val="F4F7FA"/>
-                          </a:solidFill>
-                          <a:latin typeface="Aptos" panose="020B0004020202020204" pitchFamily="34" charset="0"/>
-                        </a:rPr>
-                        <a:t>62.41</a:t>
-                      </a:r>
-                    </a:p>
-                  </a:txBody>
-                  <a:tcPr marL="88900" marR="63500" marT="50800" marB="50800">
-                    <a:lnL w="12700" cmpd="sng">
-                      <a:solidFill>
-                        <a:schemeClr val="lt1"/>
-                      </a:solidFill>
-                    </a:lnL>
-                    <a:lnR w="12700" cmpd="sng">
-                      <a:solidFill>
-                        <a:schemeClr val="lt1"/>
-                      </a:solidFill>
-                    </a:lnR>
-                    <a:lnT w="9525" cmpd="sng">
-                      <a:solidFill>
-                        <a:srgbClr val="24303C"/>
-                      </a:solidFill>
-                    </a:lnT>
-                    <a:lnB w="9525" cmpd="sng">
-                      <a:solidFill>
-                        <a:srgbClr val="24303C"/>
-                      </a:solidFill>
-                    </a:lnB>
-                    <a:solidFill>
-                      <a:srgbClr val="121923"/>
-                    </a:solidFill>
-                  </a:tcPr>
-                </a:tc>
-                <a:tc>
-                  <a:txBody>
-                    <a:bodyPr/>
-                    <a:lstStyle/>
-                    <a:p>
-                      <a:pPr>
-                        <a:spcAft>
-                          <a:spcPts val="0"/>
-                        </a:spcAft>
-                        <a:buFontTx/>
-                        <a:buNone/>
-                      </a:pPr>
-                      <a:r>
-                        <a:rPr lang="en-US" sz="1300" b="0">
-                          <a:solidFill>
-                            <a:srgbClr val="F4F7FA"/>
-                          </a:solidFill>
-                          <a:latin typeface="Aptos" panose="020B0004020202020204" pitchFamily="34" charset="0"/>
-                        </a:rPr>
-                        <a:t>351.39</a:t>
-                      </a:r>
-                    </a:p>
-                  </a:txBody>
-                  <a:tcPr marL="88900" marR="63500" marT="50800" marB="50800">
-                    <a:lnL w="12700" cmpd="sng">
-                      <a:solidFill>
-                        <a:schemeClr val="lt1"/>
-                      </a:solidFill>
-                    </a:lnL>
-                    <a:lnR w="12700" cmpd="sng">
-                      <a:solidFill>
-                        <a:schemeClr val="lt1"/>
-                      </a:solidFill>
-                    </a:lnR>
-                    <a:lnT w="9525" cmpd="sng">
-                      <a:solidFill>
-                        <a:srgbClr val="24303C"/>
-                      </a:solidFill>
-                    </a:lnT>
-                    <a:lnB w="9525" cmpd="sng">
-                      <a:solidFill>
-                        <a:srgbClr val="24303C"/>
-                      </a:solidFill>
-                    </a:lnB>
-                    <a:solidFill>
-                      <a:srgbClr val="121923"/>
-                    </a:solidFill>
-                  </a:tcPr>
-                </a:tc>
-                <a:tc>
-                  <a:txBody>
-                    <a:bodyPr/>
-                    <a:lstStyle/>
-                    <a:p>
-                      <a:pPr>
-                        <a:spcAft>
-                          <a:spcPts val="0"/>
-                        </a:spcAft>
-                        <a:buFontTx/>
-                        <a:buNone/>
-                      </a:pPr>
-                      <a:r>
-                        <a:rPr lang="en-US" sz="1300" b="0">
-                          <a:solidFill>
-                            <a:srgbClr val="F4F7FA"/>
-                          </a:solidFill>
-                          <a:latin typeface="Aptos" panose="020B0004020202020204" pitchFamily="34" charset="0"/>
-                        </a:rPr>
-                        <a:t>178,698</a:t>
-                      </a:r>
-                    </a:p>
-                  </a:txBody>
-                  <a:tcPr marL="88900" marR="63500" marT="50800" marB="50800">
-                    <a:lnL w="12700" cmpd="sng">
-                      <a:solidFill>
-                        <a:schemeClr val="lt1"/>
-                      </a:solidFill>
-                    </a:lnL>
-                    <a:lnR w="12700" cmpd="sng">
-                      <a:solidFill>
-                        <a:schemeClr val="lt1"/>
-                      </a:solidFill>
-                    </a:lnR>
-                    <a:lnT w="9525" cmpd="sng">
-                      <a:solidFill>
-                        <a:srgbClr val="24303C"/>
-                      </a:solidFill>
-                    </a:lnT>
-                    <a:lnB w="9525" cmpd="sng">
-                      <a:solidFill>
-                        <a:srgbClr val="24303C"/>
-                      </a:solidFill>
-                    </a:lnB>
-                    <a:solidFill>
-                      <a:srgbClr val="121923"/>
-                    </a:solidFill>
-                  </a:tcPr>
-                </a:tc>
-                <a:extLst>
-                  <a:ext uri="{0D108BD9-81ED-4DB2-BD59-A6C34878D82A}">
-                    <a16:rowId xmlns:a16="http://schemas.microsoft.com/office/drawing/2014/main" val="3851602889"/>
-                  </a:ext>
-                </a:extLst>
-              </a:tr>
-              <a:tr h="444500">
-                <a:tc>
-                  <a:txBody>
-                    <a:bodyPr/>
-                    <a:lstStyle/>
-                    <a:p>
-                      <a:pPr>
-                        <a:spcAft>
-                          <a:spcPts val="0"/>
-                        </a:spcAft>
-                        <a:buFontTx/>
-                        <a:buNone/>
-                      </a:pPr>
-                      <a:r>
-                        <a:rPr lang="en-US" sz="1300" b="0">
-                          <a:solidFill>
-                            <a:srgbClr val="FFB454"/>
-                          </a:solidFill>
-                          <a:latin typeface="Aptos" panose="020B0004020202020204" pitchFamily="34" charset="0"/>
-                        </a:rPr>
-                        <a:t>CUDA · 2 GPUs (DP)</a:t>
-                      </a:r>
-                    </a:p>
-                  </a:txBody>
-                  <a:tcPr marL="88900" marR="63500" marT="50800" marB="50800">
-                    <a:lnL w="12700" cmpd="sng">
-                      <a:solidFill>
-                        <a:schemeClr val="lt1"/>
-                      </a:solidFill>
-                    </a:lnL>
-                    <a:lnR w="12700" cmpd="sng">
-                      <a:solidFill>
-                        <a:schemeClr val="lt1"/>
-                      </a:solidFill>
-                    </a:lnR>
-                    <a:lnT w="9525" cmpd="sng">
-                      <a:solidFill>
-                        <a:srgbClr val="24303C"/>
-                      </a:solidFill>
-                    </a:lnT>
-                    <a:lnB w="9525" cmpd="sng">
-                      <a:solidFill>
-                        <a:srgbClr val="24303C"/>
-                      </a:solidFill>
-                    </a:lnB>
-                    <a:solidFill>
-                      <a:srgbClr val="121923"/>
-                    </a:solidFill>
-                  </a:tcPr>
-                </a:tc>
-                <a:tc>
-                  <a:txBody>
-                    <a:bodyPr/>
-                    <a:lstStyle/>
-                    <a:p>
-                      <a:pPr>
-                        <a:spcAft>
-                          <a:spcPts val="0"/>
-                        </a:spcAft>
-                        <a:buFontTx/>
-                        <a:buNone/>
-                      </a:pPr>
-                      <a:r>
-                        <a:rPr lang="en-US" sz="1300" b="0">
-                          <a:solidFill>
-                            <a:srgbClr val="F4F7FA"/>
-                          </a:solidFill>
-                          <a:latin typeface="Aptos" panose="020B0004020202020204" pitchFamily="34" charset="0"/>
-                        </a:rPr>
-                        <a:t>15.99</a:t>
-                      </a:r>
-                    </a:p>
-                  </a:txBody>
-                  <a:tcPr marL="88900" marR="63500" marT="50800" marB="50800">
-                    <a:lnL w="12700" cmpd="sng">
-                      <a:solidFill>
-                        <a:schemeClr val="lt1"/>
-                      </a:solidFill>
-                    </a:lnL>
-                    <a:lnR w="12700" cmpd="sng">
-                      <a:solidFill>
-                        <a:schemeClr val="lt1"/>
-                      </a:solidFill>
-                    </a:lnR>
-                    <a:lnT w="9525" cmpd="sng">
-                      <a:solidFill>
-                        <a:srgbClr val="24303C"/>
-                      </a:solidFill>
-                    </a:lnT>
-                    <a:lnB w="9525" cmpd="sng">
-                      <a:solidFill>
-                        <a:srgbClr val="24303C"/>
-                      </a:solidFill>
-                    </a:lnB>
-                    <a:solidFill>
-                      <a:srgbClr val="121923"/>
-                    </a:solidFill>
-                  </a:tcPr>
-                </a:tc>
-                <a:tc>
-                  <a:txBody>
-                    <a:bodyPr/>
-                    <a:lstStyle/>
-                    <a:p>
-                      <a:pPr>
-                        <a:spcAft>
-                          <a:spcPts val="0"/>
-                        </a:spcAft>
-                        <a:buFontTx/>
-                        <a:buNone/>
-                      </a:pPr>
-                      <a:r>
-                        <a:rPr lang="en-US" sz="1300" b="0">
-                          <a:solidFill>
-                            <a:srgbClr val="F4F7FA"/>
-                          </a:solidFill>
-                          <a:latin typeface="Aptos" panose="020B0004020202020204" pitchFamily="34" charset="0"/>
-                        </a:rPr>
-                        <a:t>548.40</a:t>
-                      </a:r>
-                    </a:p>
-                  </a:txBody>
-                  <a:tcPr marL="88900" marR="63500" marT="50800" marB="50800">
-                    <a:lnL w="12700" cmpd="sng">
-                      <a:solidFill>
-                        <a:schemeClr val="lt1"/>
-                      </a:solidFill>
-                    </a:lnL>
-                    <a:lnR w="12700" cmpd="sng">
-                      <a:solidFill>
-                        <a:schemeClr val="lt1"/>
-                      </a:solidFill>
-                    </a:lnR>
-                    <a:lnT w="9525" cmpd="sng">
-                      <a:solidFill>
-                        <a:srgbClr val="24303C"/>
-                      </a:solidFill>
-                    </a:lnT>
-                    <a:lnB w="9525" cmpd="sng">
-                      <a:solidFill>
-                        <a:srgbClr val="24303C"/>
-                      </a:solidFill>
-                    </a:lnB>
-                    <a:solidFill>
-                      <a:srgbClr val="121923"/>
-                    </a:solidFill>
-                  </a:tcPr>
-                </a:tc>
-                <a:tc>
-                  <a:txBody>
-                    <a:bodyPr/>
-                    <a:lstStyle/>
-                    <a:p>
-                      <a:pPr>
-                        <a:spcAft>
-                          <a:spcPts val="0"/>
-                        </a:spcAft>
-                        <a:buFontTx/>
-                        <a:buNone/>
-                      </a:pPr>
-                      <a:r>
-                        <a:rPr lang="en-US" sz="1300" b="0">
-                          <a:solidFill>
-                            <a:srgbClr val="F4F7FA"/>
-                          </a:solidFill>
-                          <a:latin typeface="Aptos" panose="020B0004020202020204" pitchFamily="34" charset="0"/>
-                        </a:rPr>
-                        <a:t>913.92</a:t>
-                      </a:r>
-                    </a:p>
-                  </a:txBody>
-                  <a:tcPr marL="88900" marR="63500" marT="50800" marB="50800">
-                    <a:lnL w="12700" cmpd="sng">
-                      <a:solidFill>
-                        <a:schemeClr val="lt1"/>
-                      </a:solidFill>
-                    </a:lnL>
-                    <a:lnR w="12700" cmpd="sng">
-                      <a:solidFill>
-                        <a:schemeClr val="lt1"/>
-                      </a:solidFill>
-                    </a:lnR>
-                    <a:lnT w="9525" cmpd="sng">
-                      <a:solidFill>
-                        <a:srgbClr val="24303C"/>
-                      </a:solidFill>
-                    </a:lnT>
-                    <a:lnB w="9525" cmpd="sng">
-                      <a:solidFill>
-                        <a:srgbClr val="24303C"/>
-                      </a:solidFill>
-                    </a:lnB>
-                    <a:solidFill>
-                      <a:srgbClr val="121923"/>
-                    </a:solidFill>
-                  </a:tcPr>
-                </a:tc>
-                <a:tc>
-                  <a:txBody>
-                    <a:bodyPr/>
-                    <a:lstStyle/>
-                    <a:p>
-                      <a:pPr>
-                        <a:spcAft>
-                          <a:spcPts val="0"/>
-                        </a:spcAft>
-                        <a:buFontTx/>
-                        <a:buNone/>
-                      </a:pPr>
-                      <a:r>
-                        <a:rPr lang="en-US" sz="1300" b="0">
-                          <a:solidFill>
-                            <a:srgbClr val="F4F7FA"/>
-                          </a:solidFill>
-                          <a:latin typeface="Aptos" panose="020B0004020202020204" pitchFamily="34" charset="0"/>
-                        </a:rPr>
-                        <a:t>29,441</a:t>
-                      </a:r>
-                    </a:p>
-                  </a:txBody>
-                  <a:tcPr marL="88900" marR="63500" marT="50800" marB="50800">
-                    <a:lnL w="12700" cmpd="sng">
-                      <a:solidFill>
-                        <a:schemeClr val="lt1"/>
-                      </a:solidFill>
-                    </a:lnL>
-                    <a:lnR w="12700" cmpd="sng">
-                      <a:solidFill>
-                        <a:schemeClr val="lt1"/>
-                      </a:solidFill>
-                    </a:lnR>
-                    <a:lnT w="9525" cmpd="sng">
-                      <a:solidFill>
-                        <a:srgbClr val="24303C"/>
-                      </a:solidFill>
-                    </a:lnT>
-                    <a:lnB w="9525" cmpd="sng">
-                      <a:solidFill>
-                        <a:srgbClr val="24303C"/>
-                      </a:solidFill>
-                    </a:lnB>
-                    <a:solidFill>
-                      <a:srgbClr val="121923"/>
-                    </a:solidFill>
-                  </a:tcPr>
-                </a:tc>
-                <a:extLst>
-                  <a:ext uri="{0D108BD9-81ED-4DB2-BD59-A6C34878D82A}">
-                    <a16:rowId xmlns:a16="http://schemas.microsoft.com/office/drawing/2014/main" val="1035485956"/>
-                  </a:ext>
-                </a:extLst>
-              </a:tr>
-              <a:tr h="444500">
-                <a:tc>
-                  <a:txBody>
-                    <a:bodyPr/>
-                    <a:lstStyle/>
-                    <a:p>
-                      <a:pPr>
-                        <a:spcAft>
-                          <a:spcPts val="0"/>
-                        </a:spcAft>
-                        <a:buFontTx/>
-                        <a:buNone/>
-                      </a:pPr>
-                      <a:r>
-                        <a:rPr lang="en-US" sz="1300" b="0">
+                        <a:rPr lang="en-US" sz="1400" b="0">
                           <a:solidFill>
                             <a:srgbClr val="A7B8FA"/>
                           </a:solidFill>
@@ -24091,13 +23383,13 @@
                         <a:buNone/>
                       </a:pPr>
                       <a:r>
-                        <a:rPr lang="en-US" sz="1300" b="0">
+                        <a:rPr lang="en-US" sz="1400" b="0">
                           <a:solidFill>
                             <a:srgbClr val="F4F7FA"/>
                           </a:solidFill>
                           <a:latin typeface="Aptos" panose="020B0004020202020204" pitchFamily="34" charset="0"/>
                         </a:rPr>
-                        <a:t>6.34</a:t>
+                        <a:t>62.49</a:t>
                       </a:r>
                     </a:p>
                   </a:txBody>
@@ -24140,13 +23432,13 @@
                         <a:buNone/>
                       </a:pPr>
                       <a:r>
-                        <a:rPr lang="en-US" sz="1300" b="0">
+                        <a:rPr lang="en-US" sz="1400" b="0">
                           <a:solidFill>
                             <a:srgbClr val="F4F7FA"/>
                           </a:solidFill>
                           <a:latin typeface="Aptos" panose="020B0004020202020204" pitchFamily="34" charset="0"/>
                         </a:rPr>
-                        <a:t>141.80</a:t>
+                        <a:t>140.33</a:t>
                       </a:r>
                     </a:p>
                   </a:txBody>
@@ -24189,13 +23481,13 @@
                         <a:buNone/>
                       </a:pPr>
                       <a:r>
-                        <a:rPr lang="en-US" sz="1300" b="0">
+                        <a:rPr lang="en-US" sz="1400" b="0">
                           <a:solidFill>
                             <a:srgbClr val="F4F7FA"/>
                           </a:solidFill>
                           <a:latin typeface="Aptos" panose="020B0004020202020204" pitchFamily="34" charset="0"/>
                         </a:rPr>
-                        <a:t>444.74</a:t>
+                        <a:t>452.48</a:t>
                       </a:r>
                     </a:p>
                   </a:txBody>
@@ -24238,13 +23530,13 @@
                         <a:buNone/>
                       </a:pPr>
                       <a:r>
-                        <a:rPr lang="en-US" sz="1300" b="0">
+                        <a:rPr lang="en-US" sz="1400" b="0">
                           <a:solidFill>
                             <a:srgbClr val="F4F7FA"/>
                           </a:solidFill>
                           <a:latin typeface="Aptos" panose="020B0004020202020204" pitchFamily="34" charset="0"/>
                         </a:rPr>
-                        <a:t>142,844</a:t>
+                        <a:t>139,617</a:t>
                       </a:r>
                     </a:p>
                   </a:txBody>
@@ -24276,11 +23568,11 @@
                 </a:tc>
                 <a:extLst>
                   <a:ext uri="{0D108BD9-81ED-4DB2-BD59-A6C34878D82A}">
-                    <a16:rowId xmlns:a16="http://schemas.microsoft.com/office/drawing/2014/main" val="1257725834"/>
+                    <a16:rowId xmlns:a16="http://schemas.microsoft.com/office/drawing/2014/main" val="85205690"/>
                   </a:ext>
                 </a:extLst>
               </a:tr>
-              <a:tr h="444500">
+              <a:tr h="520700">
                 <a:tc>
                   <a:txBody>
                     <a:bodyPr/>
@@ -24294,7 +23586,7 @@
                         <a:buNone/>
                       </a:pPr>
                       <a:r>
-                        <a:rPr lang="en-US" sz="1300" b="0">
+                        <a:rPr lang="en-US" sz="1400" b="0">
                           <a:solidFill>
                             <a:srgbClr val="FFB454"/>
                           </a:solidFill>
@@ -24343,13 +23635,13 @@
                         <a:buNone/>
                       </a:pPr>
                       <a:r>
-                        <a:rPr lang="en-US" sz="1300" b="0">
+                        <a:rPr lang="en-US" sz="1400" b="0">
                           <a:solidFill>
                             <a:srgbClr val="F4F7FA"/>
                           </a:solidFill>
                           <a:latin typeface="Aptos" panose="020B0004020202020204" pitchFamily="34" charset="0"/>
                         </a:rPr>
-                        <a:t>17.32</a:t>
+                        <a:t>165.78</a:t>
                       </a:r>
                     </a:p>
                   </a:txBody>
@@ -24392,13 +23684,13 @@
                         <a:buNone/>
                       </a:pPr>
                       <a:r>
-                        <a:rPr lang="en-US" sz="1300" b="0">
+                        <a:rPr lang="en-US" sz="1400" b="0">
                           <a:solidFill>
                             <a:srgbClr val="F4F7FA"/>
                           </a:solidFill>
                           <a:latin typeface="Aptos" panose="020B0004020202020204" pitchFamily="34" charset="0"/>
                         </a:rPr>
-                        <a:t>633.95</a:t>
+                        <a:t>632.60</a:t>
                       </a:r>
                     </a:p>
                   </a:txBody>
@@ -24441,13 +23733,13 @@
                         <a:buNone/>
                       </a:pPr>
                       <a:r>
-                        <a:rPr lang="en-US" sz="1300" b="0">
+                        <a:rPr lang="en-US" sz="1400" b="0">
                           <a:solidFill>
                             <a:srgbClr val="F4F7FA"/>
                           </a:solidFill>
                           <a:latin typeface="Aptos" panose="020B0004020202020204" pitchFamily="34" charset="0"/>
                         </a:rPr>
-                        <a:t>959.52</a:t>
+                        <a:t>961.70</a:t>
                       </a:r>
                     </a:p>
                   </a:txBody>
@@ -24490,13 +23782,13 @@
                         <a:buNone/>
                       </a:pPr>
                       <a:r>
-                        <a:rPr lang="en-US" sz="1300" b="0">
+                        <a:rPr lang="en-US" sz="1400" b="0">
                           <a:solidFill>
                             <a:srgbClr val="F4F7FA"/>
                           </a:solidFill>
                           <a:latin typeface="Aptos" panose="020B0004020202020204" pitchFamily="34" charset="0"/>
                         </a:rPr>
-                        <a:t>27,024</a:t>
+                        <a:t>28,295</a:t>
                       </a:r>
                     </a:p>
                   </a:txBody>
@@ -24528,11 +23820,11 @@
                 </a:tc>
                 <a:extLst>
                   <a:ext uri="{0D108BD9-81ED-4DB2-BD59-A6C34878D82A}">
-                    <a16:rowId xmlns:a16="http://schemas.microsoft.com/office/drawing/2014/main" val="3854377527"/>
+                    <a16:rowId xmlns:a16="http://schemas.microsoft.com/office/drawing/2014/main" val="364607179"/>
                   </a:ext>
                 </a:extLst>
               </a:tr>
-              <a:tr h="444500">
+              <a:tr h="520700">
                 <a:tc>
                   <a:txBody>
                     <a:bodyPr/>
@@ -24546,7 +23838,7 @@
                         <a:buNone/>
                       </a:pPr>
                       <a:r>
-                        <a:rPr lang="en-US" sz="1300" b="0">
+                        <a:rPr lang="en-US" sz="1400" b="0">
                           <a:solidFill>
                             <a:srgbClr val="76B900"/>
                           </a:solidFill>
@@ -24595,13 +23887,13 @@
                         <a:buNone/>
                       </a:pPr>
                       <a:r>
-                        <a:rPr lang="en-US" sz="1300" b="0">
+                        <a:rPr lang="en-US" sz="1400" b="0">
                           <a:solidFill>
                             <a:srgbClr val="F4F7FA"/>
                           </a:solidFill>
                           <a:latin typeface="Aptos" panose="020B0004020202020204" pitchFamily="34" charset="0"/>
                         </a:rPr>
-                        <a:t>5.42</a:t>
+                        <a:t>50.80</a:t>
                       </a:r>
                     </a:p>
                   </a:txBody>
@@ -24644,13 +23936,13 @@
                         <a:buNone/>
                       </a:pPr>
                       <a:r>
-                        <a:rPr lang="en-US" sz="1300" b="0">
+                        <a:rPr lang="en-US" sz="1400" b="0">
                           <a:solidFill>
                             <a:srgbClr val="F4F7FA"/>
                           </a:solidFill>
                           <a:latin typeface="Aptos" panose="020B0004020202020204" pitchFamily="34" charset="0"/>
                         </a:rPr>
-                        <a:t>41.68</a:t>
+                        <a:t>43.05</a:t>
                       </a:r>
                     </a:p>
                   </a:txBody>
@@ -24693,13 +23985,13 @@
                         <a:buNone/>
                       </a:pPr>
                       <a:r>
-                        <a:rPr lang="en-US" sz="1300" b="0">
+                        <a:rPr lang="en-US" sz="1400" b="0">
                           <a:solidFill>
                             <a:srgbClr val="F4F7FA"/>
                           </a:solidFill>
                           <a:latin typeface="Aptos" panose="020B0004020202020204" pitchFamily="34" charset="0"/>
                         </a:rPr>
-                        <a:t>379.61</a:t>
+                        <a:t>347.21</a:t>
                       </a:r>
                     </a:p>
                   </a:txBody>
@@ -24742,13 +24034,13 @@
                         <a:buNone/>
                       </a:pPr>
                       <a:r>
-                        <a:rPr lang="en-US" sz="1300" b="0">
+                        <a:rPr lang="en-US" sz="1400" b="0">
                           <a:solidFill>
                             <a:srgbClr val="F4F7FA"/>
                           </a:solidFill>
                           <a:latin typeface="Aptos" panose="020B0004020202020204" pitchFamily="34" charset="0"/>
                         </a:rPr>
-                        <a:t>169,365</a:t>
+                        <a:t>180,668</a:t>
                       </a:r>
                     </a:p>
                   </a:txBody>
@@ -24780,11 +24072,11 @@
                 </a:tc>
                 <a:extLst>
                   <a:ext uri="{0D108BD9-81ED-4DB2-BD59-A6C34878D82A}">
-                    <a16:rowId xmlns:a16="http://schemas.microsoft.com/office/drawing/2014/main" val="11042615"/>
+                    <a16:rowId xmlns:a16="http://schemas.microsoft.com/office/drawing/2014/main" val="1842148501"/>
                   </a:ext>
                 </a:extLst>
               </a:tr>
-              <a:tr h="444500">
+              <a:tr h="520700">
                 <a:tc>
                   <a:txBody>
                     <a:bodyPr/>
@@ -24798,7 +24090,7 @@
                         <a:buNone/>
                       </a:pPr>
                       <a:r>
-                        <a:rPr lang="en-US" sz="1300" b="0">
+                        <a:rPr lang="en-US" sz="1400" b="0">
                           <a:solidFill>
                             <a:srgbClr val="FFB454"/>
                           </a:solidFill>
@@ -24847,13 +24139,13 @@
                         <a:buNone/>
                       </a:pPr>
                       <a:r>
-                        <a:rPr lang="en-US" sz="1300" b="0">
+                        <a:rPr lang="en-US" sz="1400" b="0">
                           <a:solidFill>
                             <a:srgbClr val="F4F7FA"/>
                           </a:solidFill>
                           <a:latin typeface="Aptos" panose="020B0004020202020204" pitchFamily="34" charset="0"/>
                         </a:rPr>
-                        <a:t>18.39</a:t>
+                        <a:t>181.97</a:t>
                       </a:r>
                     </a:p>
                   </a:txBody>
@@ -24896,13 +24188,13 @@
                         <a:buNone/>
                       </a:pPr>
                       <a:r>
-                        <a:rPr lang="en-US" sz="1300" b="0">
+                        <a:rPr lang="en-US" sz="1400" b="0">
                           <a:solidFill>
                             <a:srgbClr val="F4F7FA"/>
                           </a:solidFill>
                           <a:latin typeface="Aptos" panose="020B0004020202020204" pitchFamily="34" charset="0"/>
                         </a:rPr>
-                        <a:t>524.17</a:t>
+                        <a:t>529.62</a:t>
                       </a:r>
                     </a:p>
                   </a:txBody>
@@ -24945,13 +24237,13 @@
                         <a:buNone/>
                       </a:pPr>
                       <a:r>
-                        <a:rPr lang="en-US" sz="1300" b="0">
+                        <a:rPr lang="en-US" sz="1400" b="0">
                           <a:solidFill>
                             <a:srgbClr val="F4F7FA"/>
                           </a:solidFill>
                           <a:latin typeface="Aptos" panose="020B0004020202020204" pitchFamily="34" charset="0"/>
                         </a:rPr>
-                        <a:t>867.08</a:t>
+                        <a:t>851.90</a:t>
                       </a:r>
                     </a:p>
                   </a:txBody>
@@ -24994,13 +24286,13 @@
                         <a:buNone/>
                       </a:pPr>
                       <a:r>
-                        <a:rPr lang="en-US" sz="1300" b="0">
+                        <a:rPr lang="en-US" sz="1400" b="0">
                           <a:solidFill>
                             <a:srgbClr val="F4F7FA"/>
                           </a:solidFill>
                           <a:latin typeface="Aptos" panose="020B0004020202020204" pitchFamily="34" charset="0"/>
                         </a:rPr>
-                        <a:t>20,903</a:t>
+                        <a:t>21,055</a:t>
                       </a:r>
                     </a:p>
                   </a:txBody>
@@ -25032,7 +24324,7 @@
                 </a:tc>
                 <a:extLst>
                   <a:ext uri="{0D108BD9-81ED-4DB2-BD59-A6C34878D82A}">
-                    <a16:rowId xmlns:a16="http://schemas.microsoft.com/office/drawing/2014/main" val="3708547252"/>
+                    <a16:rowId xmlns:a16="http://schemas.microsoft.com/office/drawing/2014/main" val="2925468081"/>
                   </a:ext>
                 </a:extLst>
               </a:tr>

</xml_diff>

<commit_message>
Explain measured GPU gains and two-GPU scaling limits
</commit_message>
<xml_diff>
--- a/presentation/CNN_CUDA_Case_Study.pptx
+++ b/presentation/CNN_CUDA_Case_Study.pptx
@@ -383,10 +383,7 @@
           <a:p>
             <a:r>
               <a:rPr lang="en-US"/>
-              <a:t>Full MNIST uses all 60,000 development images, split 48,000 train and 12,000 validation, and all 10,000 separate official test images. Splits preserve digit proportions. The same initial bytes, exact splits, per-epoch shuffle, FP32 precision, global batch 64, seed 42, SGD learning rate 0.05 and momentum 0.9 are used in every path. TF32 is disabled. Each path completes 50 epochs and 37,500 optimizer steps.
-Training sums synchronized training epochs, excluding warmup, validation, initial upload and checkpoint I/O. Conv and inference are warmed median completed-call wall times for one resident digit. Batch/s uses full-CNN inference at batch 64. Single-image DataParallel uses one replica. No energy or monetary rate was measured.
-Final test accuracy: PyTorch CPU: 97.13%; cuDNN: 97.17%; cuDNN DP: 97.17%; PyTorch: 97.17%; PyTorch DP: 97.15%. This is one seed and one runtime. Full-data timings are measured anew and are not extrapolated from the earlier 10% study.
-Source: https://github.com/saltypal/CNN-CUDA-Case-Study/tree/42624fca4ba9b278076097e076363057b2d32a27/src/hpc_cnn</a:t>
+              <a:t>CPU-relative ratios use matched full-MNIST runs: PyTorch one-GPU training 94.592346674/50.799344737=1.8621x, time reduction 46.2966%; cuDNN one-GPU 1.5137x. Batch-64 throughput ratios are CPU latency divided by GPU latency: PyTorch 2.9887x, cuDNN 2.3097x. Resident-input warm medians; training excludes warmup, validation and I/O. Conv and Infer are batch-one, not batch-64. PyTorch GPU dispatches cuDNN; these are different program interfaces and algorithm selection, not independent hardware technologies.</a:t>
             </a:r>
             <a:endParaRPr lang="en-US" dirty="0"/>
           </a:p>
@@ -474,9 +471,7 @@
           <a:p>
             <a:r>
               <a:rPr lang="en-US"/>
-              <a:t>Matching one- and two-GPU engines retain global batch 64. Training speedup is T1/T2. Efficiency is T1/(2*T2). GPU-time cost ratio is 2*T2/T1, a time-based resource proxy. cuDNN: speedup 0.377, efficiency 18.85%, GPU-time ratio 5.31; PyTorch: speedup 0.279, efficiency 13.96%, GPU-time ratio 7.16.
-DataParallel adds replication, scatter, gather and gradient reduction. Using more training images increases the number of steps; it does not increase the per-GPU batch, which remains 32. No detailed profiler attribution was collected to assign an exact overhead percentage to each component. No utilization telemetry or batch-size sweep was measured. Energy was not measured and no currency rate was supplied.
-https://github.com/saltypal/CNN-CUDA-Case-Study/tree/42624fca4ba9b278076097e076363057b2d32a27/src/hpc_cnn</a:t>
+              <a:t>Dashed cyan line is the measured CPU training baseline 94.59 seconds. cuDNN two-GPU 165.78 seconds is 1.7526x slower than CPU; PyTorch two-GPU 181.97 seconds is 1.9237x slower. Same-engine one-to-two GPU speedup gives efficiency (T1/T2)/2: 18.85% cuDNN, 13.96% PyTorch. GPU-time proxy 2*T2/T1 is 5.31x and 7.16x, not money or energy. Replication, scatter/gather and gradient reduction are expected overhead mechanisms; their individual timing shares were not profiled. More dataset images add steps, not more work per replica at fixed global batch64.</a:t>
             </a:r>
             <a:endParaRPr lang="en-US" dirty="0"/>
           </a:p>
@@ -564,9 +559,7 @@
           <a:p>
             <a:r>
               <a:rPr lang="en-US"/>
-              <a:t>All five final models were evaluated on the complete official 10,000-image test set. Accuracy: PyTorch CPU: 97.13%; cuDNN: 97.17%; cuDNN DP: 97.17%; PyTorch: 97.17%; PyTorch DP: 97.15%. These are separately trained final checkpoints; reduction order can create small differences in training trajectories. Final predictions need not be byte-identical.
-All 119 numerical validation checks passed. The maximum forward absolute error at matched input and weights is 3.58e-07; it is not a final training accuracy difference or gradient error maximum. The independent audit checked every test prediction, exact dataset coverage, identical initial parameter bytes, exact split indices, 50 epoch histories, timing sums and Git provenance.
-Source: https://github.com/saltypal/CNN-CUDA-Case-Study/tree/42624fca4ba9b278076097e076363057b2d32a27/src/hpc_cnn</a:t>
+              <a:t>All five epoch50 checkpoints were evaluated on the same10000 held-out digits. CPU97.13%, cuDNN1 and2 GPU97.17%, PyTorch1 GPU97.17%, PyTorch2 GPU97.15%. Single seed/runtime, so these small differences do not establish an accuracy advantage.119 numerical checks pass, including forward and all gradients. Parallel work, tiling/data reuse, resident VRAM and amortized launch overhead explain why larger batched operations can favor GPU hardware. These are architectural explanations, not measured utilization or an overhead decomposition.</a:t>
             </a:r>
             <a:endParaRPr lang="en-US" dirty="0"/>
           </a:p>
@@ -654,11 +647,7 @@
           <a:p>
             <a:r>
               <a:rPr lang="en-US"/>
-              <a:t>Discuss measured workloads rather than a universal GPU ranking. Lowest training time: PyTorch, 50.80 s. Lowest single-digit inference latency: PyTorch CPU, 88.96 microseconds. Highest batch-64 inference throughput: PyTorch, 180,668 images/s.
-Demo: load all five final checkpoints and predict the same full-test-set digits. This does not retrain. Cold checkpoint loading is separate from warmed latency. Run in the completed two-GPU Kaggle environment:
-cd /kaggle/working/cnn-cuda-case-study-source
-PYTHONPATH=src python -m hpc_cnn.demo --config /kaggle/working/cnn-cuda-case-study-full-mnist-results/run_config_full_mnist.json --run-root /kaggle/working/cnn-cuda-case-study-full-mnist-results
-Source: https://github.com/saltypal/CNN-CUDA-Case-Study/tree/42624fca4ba9b278076097e076363057b2d32a27/src/hpc_cnn</a:t>
+              <a:t>One T4 is the measured performance choice for this model/globalbatch64. Two GPUs could benefit a larger global batch or more computation per sample, but this study did not run that sweep. DataParallel replicates the entire model on every device, splits input, gathers logits, sums replica gradients onto the original module and performs one optimizer step; it is not model sharding and does not allow a model larger than one GPU simply by adding devices. CPU has lower latency for one digit. The demo uses the five actual trained checkpoints. Source commit42624fca4ba9b278076097e076363057b2d32a27; full results/checkpoints releasev2.0.0. https://docs.pytorch.org/docs/main/generated/torch.nn.DataParallel.html</a:t>
             </a:r>
             <a:endParaRPr lang="en-US" dirty="0"/>
           </a:p>
@@ -1582,7 +1571,7 @@
           </a:prstGeom>
           <a:extLst>
             <a:ext uri="{C572A759-6A51-4108-AA02-DFA0A04FC94B}">
-              <ma14:wrappingTextBoxFlag xmlns="" xmlns:ma14="http://schemas.microsoft.com/office/mac/drawingml/2011/main" val="0"/>
+              <ma14:wrappingTextBoxFlag xmlns:ma14="http://schemas.microsoft.com/office/mac/drawingml/2011/main" xmlns="" val="0"/>
             </a:ext>
           </a:extLst>
         </p:spPr>
@@ -1657,7 +1646,7 @@
           </a:prstGeom>
           <a:extLst>
             <a:ext uri="{C572A759-6A51-4108-AA02-DFA0A04FC94B}">
-              <ma14:wrappingTextBoxFlag xmlns="" xmlns:ma14="http://schemas.microsoft.com/office/mac/drawingml/2011/main" val="0"/>
+              <ma14:wrappingTextBoxFlag xmlns:ma14="http://schemas.microsoft.com/office/mac/drawingml/2011/main" xmlns="" val="0"/>
             </a:ext>
           </a:extLst>
         </p:spPr>
@@ -3758,7 +3747,7 @@
           </a:prstGeom>
           <a:extLst>
             <a:ext uri="{C572A759-6A51-4108-AA02-DFA0A04FC94B}">
-              <ma14:wrappingTextBoxFlag xmlns="" xmlns:ma14="http://schemas.microsoft.com/office/mac/drawingml/2011/main" val="0"/>
+              <ma14:wrappingTextBoxFlag xmlns:ma14="http://schemas.microsoft.com/office/mac/drawingml/2011/main" xmlns="" val="0"/>
             </a:ext>
           </a:extLst>
         </p:spPr>
@@ -3842,7 +3831,7 @@
                   <a:srgbClr val="F4F7FA"/>
                 </a:solidFill>
               </a:rPr>
-              <a:t>Results 1/4 — Measured CNN performance</a:t>
+              <a:t>Results 1/4 — One GPU beats CPU at batch 64</a:t>
             </a:r>
             <a:endParaRPr lang="en-US" sz="2600" dirty="0"/>
           </a:p>
@@ -3880,7 +3869,7 @@
                   <a:srgbClr val="7E8A97"/>
                 </a:solidFill>
               </a:rPr>
-              <a:t>50 epochs · 48,000 train / 12,000 validation / 10,000 test · same CNN, initialization and batch 64.</a:t>
+              <a:t>Same CNN, full MNIST, 50 epochs: compare completed training time and batched inference throughput.</a:t>
             </a:r>
             <a:endParaRPr lang="en-US" sz="1150" dirty="0"/>
           </a:p>
@@ -3972,7 +3961,7 @@
                   <a:srgbClr val="A3E635"/>
                 </a:solidFill>
               </a:rPr>
-              <a:t>FASTEST TRAINING</a:t>
+              <a:t>ONE T4 vs CPU</a:t>
             </a:r>
             <a:endParaRPr lang="en-US" sz="1200" dirty="0"/>
           </a:p>
@@ -4005,14 +3994,14 @@
               <a:buNone/>
             </a:pPr>
             <a:r>
-              <a:rPr lang="en-US" sz="3600" b="1">
+              <a:rPr lang="en-US" sz="2600" b="1">
                 <a:solidFill>
                   <a:srgbClr val="F4F7FA"/>
                 </a:solidFill>
               </a:rPr>
-              <a:t>50.80 s</a:t>
-            </a:r>
-            <a:endParaRPr lang="en-US" sz="3600" dirty="0"/>
+              <a:t>1.86× faster</a:t>
+            </a:r>
+            <a:endParaRPr lang="en-US" sz="2600" dirty="0"/>
           </a:p>
         </p:txBody>
       </p:sp>
@@ -4043,12 +4032,12 @@
               <a:buNone/>
             </a:pPr>
             <a:r>
-              <a:rPr lang="en-US" sz="1100">
+              <a:rPr lang="en-US" sz="1050">
                 <a:solidFill>
                   <a:srgbClr val="7E8A97"/>
                 </a:solidFill>
               </a:rPr>
-              <a:t>PyTorch · one T4</a:t>
+              <a:t>PyTorch training: 50.80 vs 94.59 s</a:t>
             </a:r>
           </a:p>
           <a:p>
@@ -4056,14 +4045,14 @@
               <a:buNone/>
             </a:pPr>
             <a:r>
-              <a:rPr lang="en-US" sz="1100">
+              <a:rPr lang="en-US" sz="1050">
                 <a:solidFill>
                   <a:srgbClr val="7E8A97"/>
                 </a:solidFill>
               </a:rPr>
-              <a:t>1.86× vs CPU</a:t>
-            </a:r>
-            <a:endParaRPr lang="en-US" sz="1100" dirty="0"/>
+              <a:t>46.3% less training time</a:t>
+            </a:r>
+            <a:endParaRPr lang="en-US" sz="1050" dirty="0"/>
           </a:p>
         </p:txBody>
       </p:sp>
@@ -4076,7 +4065,7 @@
         <p:spPr>
           <a:xfrm>
             <a:off x="8668512" y="4114800"/>
-            <a:ext cx="2011680" cy="228600"/>
+            <a:ext cx="2298700" cy="228600"/>
           </a:xfrm>
           <a:prstGeom prst="rect">
             <a:avLst/>
@@ -4099,7 +4088,7 @@
                   <a:srgbClr val="FFB454"/>
                 </a:solidFill>
               </a:rPr>
-              <a:t>Latency vs throughput</a:t>
+              <a:t>2.99× batch throughput</a:t>
             </a:r>
             <a:endParaRPr lang="en-US" sz="1300" dirty="0"/>
           </a:p>
@@ -4114,7 +4103,7 @@
         <p:spPr>
           <a:xfrm>
             <a:off x="8668512" y="4462272"/>
-            <a:ext cx="2084832" cy="1005840"/>
+            <a:ext cx="2286000" cy="1005840"/>
           </a:xfrm>
           <a:prstGeom prst="rect">
             <a:avLst/>
@@ -4132,12 +4121,12 @@
               <a:buNone/>
             </a:pPr>
             <a:r>
-              <a:rPr lang="en-US" sz="1170">
+              <a:rPr lang="en-US" sz="1150">
                 <a:solidFill>
                   <a:srgbClr val="C7D0D9"/>
                 </a:solidFill>
               </a:rPr>
-              <a:t>PyTorch CPU: 88.96 µs per digit.</a:t>
+              <a:t>PyTorch: 180,668 vs 60,449 img/s.</a:t>
             </a:r>
           </a:p>
           <a:p>
@@ -4145,12 +4134,12 @@
               <a:buNone/>
             </a:pPr>
             <a:r>
-              <a:rPr lang="en-US" sz="1170">
+              <a:rPr lang="en-US" sz="1150">
                 <a:solidFill>
                   <a:srgbClr val="C7D0D9"/>
                 </a:solidFill>
               </a:rPr>
-              <a:t>PyTorch: 180,668 batch img/s.</a:t>
+              <a:t>cuDNN: 1.51× faster training;</a:t>
             </a:r>
           </a:p>
           <a:p>
@@ -4158,14 +4147,14 @@
               <a:buNone/>
             </a:pPr>
             <a:r>
-              <a:rPr lang="en-US" sz="1170">
+              <a:rPr lang="en-US" sz="1150">
                 <a:solidFill>
                   <a:srgbClr val="C7D0D9"/>
                 </a:solidFill>
               </a:rPr>
-              <a:t>Choose by workload size.</a:t>
-            </a:r>
-            <a:endParaRPr lang="en-US" sz="1170" dirty="0"/>
+              <a:t>2.31× CPU batch throughput.</a:t>
+            </a:r>
+            <a:endParaRPr lang="en-US" sz="1150" dirty="0"/>
           </a:p>
         </p:txBody>
       </p:sp>
@@ -4201,7 +4190,7 @@
                   <a:srgbClr val="F4F7FA"/>
                 </a:solidFill>
               </a:rPr>
-              <a:t>Conv/Infer: one-digit µs, resident input. Batch/s: batch-64 inference.</a:t>
+              <a:t>Batch/s uses 64 images; Conv/Infer are one-digit µs. CPU wins tiny-call latency.</a:t>
             </a:r>
           </a:p>
           <a:p>
@@ -4214,7 +4203,7 @@
                   <a:srgbClr val="F4F7FA"/>
                 </a:solidFill>
               </a:rPr>
-              <a:t>Training excludes warmup/validation/I/O; batch-one DP uses one replica.</a:t>
+              <a:t>GPU speedup comes from enough work per launch; all five configurations are shown.</a:t>
             </a:r>
             <a:endParaRPr lang="en-US" sz="1150" dirty="0"/>
           </a:p>
@@ -4240,7 +4229,7 @@
           </a:prstGeom>
           <a:extLst>
             <a:ext uri="{C572A759-6A51-4108-AA02-DFA0A04FC94B}">
-              <ma14:wrappingTextBoxFlag xmlns="" xmlns:ma14="http://schemas.microsoft.com/office/mac/drawingml/2011/main" val="0"/>
+              <ma14:wrappingTextBoxFlag xmlns:ma14="http://schemas.microsoft.com/office/mac/drawingml/2011/main" xmlns="" val="0"/>
             </a:ext>
           </a:extLst>
         </p:spPr>
@@ -5907,7 +5896,7 @@
                   <a:srgbClr val="F4F7FA"/>
                 </a:solidFill>
               </a:rPr>
-              <a:t>Results 2/4 — Two-GPU scaling and overhead</a:t>
+              <a:t>Results 2/4 — Two GPUs: more hardware, more overhead</a:t>
             </a:r>
             <a:endParaRPr lang="en-US" sz="2600" dirty="0"/>
           </a:p>
@@ -5945,7 +5934,7 @@
                   <a:srgbClr val="7E8A97"/>
                 </a:solidFill>
               </a:rPr>
-              <a:t>Matching engines, same global batch 64. Two GPUs increased training time in the full-MNIST run.</a:t>
+              <a:t>One T4 beats CPU; two T4s lose here. Global batch 64 leaves only 32 images of work on each replica.</a:t>
             </a:r>
             <a:endParaRPr lang="en-US" sz="1150" dirty="0"/>
           </a:p>
@@ -6523,7 +6512,7 @@
                   <a:srgbClr val="F4F7FA"/>
                 </a:solidFill>
               </a:rPr>
-              <a:t>Two GPUs took 2.65–3.58× longer</a:t>
+              <a:t>CPU reference: 94.59 s for 50 epochs</a:t>
             </a:r>
             <a:endParaRPr lang="en-US" sz="1250" dirty="0"/>
           </a:p>
@@ -6619,7 +6608,7 @@
                   <a:srgbClr val="76B900"/>
                 </a:solidFill>
               </a:rPr>
-              <a:t>EFFICIENCY &amp; COST</a:t>
+              <a:t>WHY TWO GPUs LOST HERE</a:t>
             </a:r>
             <a:endParaRPr lang="en-US" sz="850" dirty="0"/>
           </a:p>
@@ -6657,7 +6646,7 @@
                   <a:srgbClr val="F4F7FA"/>
                 </a:solidFill>
               </a:rPr>
-              <a:t>Efficiency = (T1 / T2) ÷ 2</a:t>
+              <a:t>Training time relative to CPU</a:t>
             </a:r>
             <a:endParaRPr lang="en-US" sz="1150" dirty="0"/>
           </a:p>
@@ -6690,14 +6679,14 @@
               <a:buNone/>
             </a:pPr>
             <a:r>
-              <a:rPr lang="en-US" sz="2400" b="1">
+              <a:rPr lang="en-US" sz="2200" b="1">
                 <a:solidFill>
                   <a:srgbClr val="76B900"/>
                 </a:solidFill>
               </a:rPr>
-              <a:t>14.0–18.8%</a:t>
-            </a:r>
-            <a:endParaRPr lang="en-US" sz="2400" dirty="0">
+              <a:t>1.75–1.92× slower</a:t>
+            </a:r>
+            <a:endParaRPr lang="en-US" sz="2200" dirty="0">
               <a:solidFill>
                 <a:srgbClr val="76B900"/>
               </a:solidFill>
@@ -6737,7 +6726,7 @@
                   <a:srgbClr val="F4F7FA"/>
                 </a:solidFill>
               </a:rPr>
-              <a:t>GPU-time cost = 2 × T2 / T1</a:t>
+              <a:t>Two GPUs vs one: scaling efficiency</a:t>
             </a:r>
             <a:endParaRPr lang="en-US" sz="1150" dirty="0"/>
           </a:p>
@@ -6775,7 +6764,7 @@
                   <a:srgbClr val="FFB454"/>
                 </a:solidFill>
               </a:rPr>
-              <a:t>5.31–7.16×</a:t>
+              <a:t>14.0–18.8%</a:t>
             </a:r>
             <a:endParaRPr lang="en-US" sz="2000" dirty="0">
               <a:solidFill>
@@ -6852,7 +6841,7 @@
         <p:spPr>
           <a:xfrm>
             <a:off x="7644384" y="4046220"/>
-            <a:ext cx="1905000" cy="128016"/>
+            <a:ext cx="3048000" cy="128016"/>
           </a:xfrm>
           <a:prstGeom prst="rect">
             <a:avLst/>
@@ -6875,7 +6864,7 @@
                   <a:srgbClr val="FFB454"/>
                 </a:solidFill>
               </a:rPr>
-              <a:t>TWO-GPU TRADEOFF</a:t>
+              <a:t>WORK vs COORDINATION</a:t>
             </a:r>
             <a:endParaRPr lang="en-US" sz="850" dirty="0"/>
           </a:p>
@@ -6909,12 +6898,12 @@
               <a:buChar char="•"/>
             </a:pPr>
             <a:r>
-              <a:rPr lang="en-US" sz="1320">
+              <a:rPr lang="en-US" sz="1200">
                 <a:solidFill>
                   <a:srgbClr val="C7D0D9"/>
                 </a:solidFill>
               </a:rPr>
-              <a:t>Replicate, scatter/gather, reduce gradients</a:t>
+              <a:t>32 images/GPU: too little useful work</a:t>
             </a:r>
           </a:p>
           <a:p>
@@ -6923,12 +6912,12 @@
               <a:buChar char="•"/>
             </a:pPr>
             <a:r>
-              <a:rPr lang="en-US" sz="1320">
+              <a:rPr lang="en-US" sz="1200">
                 <a:solidFill>
                   <a:srgbClr val="C7D0D9"/>
                 </a:solidFill>
               </a:rPr>
-              <a:t>More images add steps; each GPU still gets 32</a:t>
+              <a:t>Replicate + copy + gather + gradient sums</a:t>
             </a:r>
           </a:p>
           <a:p>
@@ -6937,14 +6926,28 @@
               <a:buChar char="•"/>
             </a:pPr>
             <a:r>
-              <a:rPr lang="en-US" sz="1320">
+              <a:rPr lang="en-US" sz="1200">
                 <a:solidFill>
                   <a:srgbClr val="C7D0D9"/>
                 </a:solidFill>
               </a:rPr>
-              <a:t>GPU-time is a proxy; energy/currency not measured</a:t>
-            </a:r>
-            <a:endParaRPr lang="en-US" sz="1320" dirty="0"/>
+              <a:t>GPU-time cost: 5.31–7.16× one GPU</a:t>
+            </a:r>
+          </a:p>
+          <a:p>
+            <a:pPr marL="177800" indent="-177800">
+              <a:buSzPct val="100000"/>
+              <a:buChar char="•"/>
+            </a:pPr>
+            <a:r>
+              <a:rPr lang="en-US" sz="1200">
+                <a:solidFill>
+                  <a:srgbClr val="C7D0D9"/>
+                </a:solidFill>
+              </a:rPr>
+              <a:t>Larger per-GPU work may amortize costs</a:t>
+            </a:r>
+            <a:endParaRPr lang="en-US" sz="1200" dirty="0"/>
           </a:p>
         </p:txBody>
       </p:sp>
@@ -6968,7 +6971,7 @@
           </a:prstGeom>
           <a:extLst>
             <a:ext uri="{C572A759-6A51-4108-AA02-DFA0A04FC94B}">
-              <ma14:wrappingTextBoxFlag xmlns="" xmlns:ma14="http://schemas.microsoft.com/office/mac/drawingml/2011/main" val="0"/>
+              <ma14:wrappingTextBoxFlag xmlns:ma14="http://schemas.microsoft.com/office/mac/drawingml/2011/main" xmlns="" val="0"/>
             </a:ext>
           </a:extLst>
         </p:spPr>
@@ -7359,6 +7362,48 @@
           </a:p>
         </p:txBody>
       </p:sp>
+      <p:cxnSp>
+        <p:nvCxnSpPr>
+          <p:cNvPr id="4" name="Straight Connector 3">
+            <a:extLst>
+              <a:ext uri="{FF2B5EF4-FFF2-40B4-BE49-F238E27FC236}">
+                <a16:creationId xmlns:a16="http://schemas.microsoft.com/office/drawing/2014/main" id="{06E05EA1-3767-2653-F63E-C71497E79979}"/>
+              </a:ext>
+            </a:extLst>
+          </p:cNvPr>
+          <p:cNvCxnSpPr/>
+          <p:nvPr/>
+        </p:nvCxnSpPr>
+        <p:spPr>
+          <a:xfrm>
+            <a:off x="1625600" y="3987145"/>
+            <a:ext cx="4470400" cy="0"/>
+          </a:xfrm>
+          <a:prstGeom prst="line">
+            <a:avLst/>
+          </a:prstGeom>
+          <a:ln w="19050">
+            <a:solidFill>
+              <a:srgbClr val="00FFFF"/>
+            </a:solidFill>
+            <a:prstDash val="dash"/>
+          </a:ln>
+        </p:spPr>
+        <p:style>
+          <a:lnRef idx="1">
+            <a:schemeClr val="accent1"/>
+          </a:lnRef>
+          <a:fillRef idx="0">
+            <a:schemeClr val="accent1"/>
+          </a:fillRef>
+          <a:effectRef idx="0">
+            <a:schemeClr val="accent1"/>
+          </a:effectRef>
+          <a:fontRef idx="minor">
+            <a:schemeClr val="tx1"/>
+          </a:fontRef>
+        </p:style>
+      </p:cxnSp>
     </p:spTree>
   </p:cSld>
   <p:clrMapOvr>
@@ -7416,7 +7461,7 @@
                   <a:srgbClr val="F4F7FA"/>
                 </a:solidFill>
               </a:rPr>
-              <a:t>Results 3/4 — Accuracy and numerical checks</a:t>
+              <a:t>Results 3/4 — Faster GPU execution, same task quality</a:t>
             </a:r>
             <a:endParaRPr lang="en-US" sz="2600" dirty="0"/>
           </a:p>
@@ -7454,7 +7499,7 @@
                   <a:srgbClr val="7E8A97"/>
                 </a:solidFill>
               </a:rPr>
-              <a:t>Five final models evaluated on all 10,000 official test digits. All 119 numerical checks passed.</a:t>
+              <a:t>GPU acceleration changes how the math executes. It does not inherently make the classifier more accurate.</a:t>
             </a:r>
             <a:endParaRPr lang="en-US" sz="1150" dirty="0"/>
           </a:p>
@@ -8383,12 +8428,12 @@
               <a:buNone/>
             </a:pPr>
             <a:r>
-              <a:rPr lang="en-US" sz="850" b="1" kern="0" spc="100" dirty="0">
+              <a:rPr lang="en-US" sz="850" b="1" kern="0" spc="100">
                 <a:solidFill>
                   <a:srgbClr val="FFB454"/>
                 </a:solidFill>
               </a:rPr>
-              <a:t>INFERENCE</a:t>
+              <a:t>GPU MECHANISM</a:t>
             </a:r>
             <a:endParaRPr lang="en-US" sz="850" dirty="0"/>
           </a:p>
@@ -8422,12 +8467,12 @@
               <a:buChar char="•"/>
             </a:pPr>
             <a:r>
-              <a:rPr lang="en-US" sz="1320">
+              <a:rPr lang="en-US" sz="1250">
                 <a:solidFill>
                   <a:srgbClr val="C7D0D9"/>
                 </a:solidFill>
               </a:rPr>
-              <a:t>10,000 held-out digits per model</a:t>
+              <a:t>Many image/filter outputs run together</a:t>
             </a:r>
           </a:p>
           <a:p>
@@ -8436,12 +8481,12 @@
               <a:buChar char="•"/>
             </a:pPr>
             <a:r>
-              <a:rPr lang="en-US" sz="1320">
+              <a:rPr lang="en-US" sz="1250">
                 <a:solidFill>
                   <a:srgbClr val="C7D0D9"/>
                 </a:solidFill>
               </a:rPr>
-              <a:t>Final accuracy: 97.13–97.17%</a:t>
+              <a:t>Library tiling reuses input and weights</a:t>
             </a:r>
           </a:p>
           <a:p>
@@ -8450,12 +8495,12 @@
               <a:buChar char="•"/>
             </a:pPr>
             <a:r>
-              <a:rPr lang="en-US" sz="1320">
+              <a:rPr lang="en-US" sz="1250">
                 <a:solidFill>
                   <a:srgbClr val="C7D0D9"/>
                 </a:solidFill>
               </a:rPr>
-              <a:t>Same splits, initial weights and FP32 setup</a:t>
+              <a:t>VRAM keeps tensors near GPU compute</a:t>
             </a:r>
           </a:p>
           <a:p>
@@ -8464,14 +8509,14 @@
               <a:buChar char="•"/>
             </a:pPr>
             <a:r>
-              <a:rPr lang="en-US" sz="1320">
+              <a:rPr lang="en-US" sz="1250">
                 <a:solidFill>
                   <a:srgbClr val="C7D0D9"/>
                 </a:solidFill>
               </a:rPr>
-              <a:t>Checks cover forward and all gradients</a:t>
-            </a:r>
-            <a:endParaRPr lang="en-US" sz="1320" dirty="0"/>
+              <a:t>Batch 64 shares launch cost across images</a:t>
+            </a:r>
+            <a:endParaRPr lang="en-US" sz="1250" dirty="0"/>
           </a:p>
         </p:txBody>
       </p:sp>
@@ -8502,14 +8547,14 @@
               <a:buNone/>
             </a:pPr>
             <a:r>
-              <a:rPr lang="en-US" sz="1220" b="1">
+              <a:rPr lang="en-US" sz="1100" b="1">
                 <a:solidFill>
                   <a:srgbClr val="A3E635"/>
                 </a:solidFill>
               </a:rPr>
-              <a:t>Small training differences; no failed kernel checks.</a:t>
-            </a:r>
-            <a:endParaRPr lang="en-US" sz="1220" dirty="0"/>
+              <a:t>Mechanism explains the trend; no utilization profile.</a:t>
+            </a:r>
+            <a:endParaRPr lang="en-US" sz="1100" dirty="0"/>
           </a:p>
         </p:txBody>
       </p:sp>
@@ -8533,7 +8578,7 @@
           </a:prstGeom>
           <a:extLst>
             <a:ext uri="{C572A759-6A51-4108-AA02-DFA0A04FC94B}">
-              <ma14:wrappingTextBoxFlag xmlns="" xmlns:ma14="http://schemas.microsoft.com/office/mac/drawingml/2011/main" val="0"/>
+              <ma14:wrappingTextBoxFlag xmlns:ma14="http://schemas.microsoft.com/office/mac/drawingml/2011/main" xmlns="" val="0"/>
             </a:ext>
           </a:extLst>
         </p:spPr>
@@ -8617,7 +8662,7 @@
                   <a:srgbClr val="F4F7FA"/>
                 </a:solidFill>
               </a:rPr>
-              <a:t>Results 4/4 — Inferences and live demo</a:t>
+              <a:t>Results 4/4 — When to choose one GPU or two</a:t>
             </a:r>
             <a:endParaRPr lang="en-US" sz="2600" dirty="0"/>
           </a:p>
@@ -8655,7 +8700,7 @@
                   <a:srgbClr val="7E8A97"/>
                 </a:solidFill>
               </a:rPr>
-              <a:t>Full MNIST, same CNN and setup. Compare request latency, training time and batched throughput separately.</a:t>
+              <a:t>Choose by useful work per step: our measured winner is one T4; multi-GPU gains need a heavier workload.</a:t>
             </a:r>
             <a:endParaRPr lang="en-US" sz="1150" dirty="0"/>
           </a:p>
@@ -8783,7 +8828,7 @@
                   <a:srgbClr val="41D9FF"/>
                 </a:solidFill>
               </a:rPr>
-              <a:t>Convolution exposes parallel work</a:t>
+              <a:t>One GPU: measured training gain</a:t>
             </a:r>
             <a:endParaRPr lang="en-US" sz="1550" dirty="0"/>
           </a:p>
@@ -8821,7 +8866,7 @@
                   <a:srgbClr val="C7D0D9"/>
                 </a:solidFill>
               </a:rPr>
-              <a:t>Independent outputs run together.</a:t>
+              <a:t>PyTorch: 1.86× CPU speed; cuDNN: 1.51×.</a:t>
             </a:r>
           </a:p>
           <a:p>
@@ -8834,7 +8879,7 @@
                   <a:srgbClr val="C7D0D9"/>
                 </a:solidFill>
               </a:rPr>
-              <a:t>Weight gradients combine contributions;</a:t>
+              <a:t>Parallel dot products and data reuse help</a:t>
             </a:r>
           </a:p>
           <a:p>
@@ -8847,7 +8892,7 @@
                   <a:srgbClr val="C7D0D9"/>
                 </a:solidFill>
               </a:rPr>
-              <a:t>the optimizer waits for their completion.</a:t>
+              <a:t>when compute outweighs launch overhead.</a:t>
             </a:r>
             <a:endParaRPr lang="en-US" sz="1250" dirty="0"/>
           </a:p>
@@ -8975,7 +9020,7 @@
                   <a:srgbClr val="76B900"/>
                 </a:solidFill>
               </a:rPr>
-              <a:t>PyTorch CPU wins digit latency</a:t>
+              <a:t>Batching makes the GPU pay off</a:t>
             </a:r>
             <a:endParaRPr lang="en-US" sz="1550" dirty="0"/>
           </a:p>
@@ -8990,7 +9035,7 @@
         <p:spPr>
           <a:xfrm>
             <a:off x="7214616" y="2112264"/>
-            <a:ext cx="3886200" cy="530352"/>
+            <a:ext cx="3886200" cy="736600"/>
           </a:xfrm>
           <a:prstGeom prst="rect">
             <a:avLst/>
@@ -9013,7 +9058,33 @@
                   <a:srgbClr val="C7D0D9"/>
                 </a:solidFill>
               </a:rPr>
-              <a:t>88.96 µs per digit in this run. Framework and launch overhead matter.</a:t>
+              <a:t>PyTorch batch 64: 2.99× CPU throughput.</a:t>
+            </a:r>
+          </a:p>
+          <a:p>
+            <a:pPr marL="0" indent="0">
+              <a:buNone/>
+            </a:pPr>
+            <a:r>
+              <a:rPr lang="en-US" sz="1250">
+                <a:solidFill>
+                  <a:srgbClr val="C7D0D9"/>
+                </a:solidFill>
+              </a:rPr>
+              <a:t>64 images share launches and filter weights.</a:t>
+            </a:r>
+          </a:p>
+          <a:p>
+            <a:pPr marL="0" indent="0">
+              <a:buNone/>
+            </a:pPr>
+            <a:r>
+              <a:rPr lang="en-US" sz="1250">
+                <a:solidFill>
+                  <a:srgbClr val="C7D0D9"/>
+                </a:solidFill>
+              </a:rPr>
+              <a:t>CPU still wins one-digit latency: 88.96 µs.</a:t>
             </a:r>
             <a:endParaRPr lang="en-US" sz="1250" dirty="0"/>
           </a:p>
@@ -9141,7 +9212,7 @@
                   <a:srgbClr val="A78BFA"/>
                 </a:solidFill>
               </a:rPr>
-              <a:t>PyTorch / 1 GPU wins training</a:t>
+              <a:t>Two GPUs: potential, not a win here</a:t>
             </a:r>
             <a:endParaRPr lang="en-US" sz="1550" dirty="0"/>
           </a:p>
@@ -9179,7 +9250,7 @@
                   <a:srgbClr val="C7D0D9"/>
                 </a:solidFill>
               </a:rPr>
-              <a:t>50.80 s for 50 epochs vs CPU 94.59 s.</a:t>
+              <a:t>More workers can process a larger global batch.</a:t>
             </a:r>
           </a:p>
           <a:p>
@@ -9192,7 +9263,7 @@
                   <a:srgbClr val="C7D0D9"/>
                 </a:solidFill>
               </a:rPr>
-              <a:t>Batch-64 inference: 180,668 images/s.</a:t>
+              <a:t>Each replica needs enough work to hide copies</a:t>
             </a:r>
           </a:p>
           <a:p>
@@ -9205,7 +9276,7 @@
                   <a:srgbClr val="C7D0D9"/>
                 </a:solidFill>
               </a:rPr>
-              <a:t>Latency and throughput have different winners.</a:t>
+              <a:t>and gradient reduction. No larger-batch trial.</a:t>
             </a:r>
             <a:endParaRPr lang="en-US" sz="1250" dirty="0"/>
           </a:p>
@@ -9333,7 +9404,7 @@
                   <a:srgbClr val="FFB454"/>
                 </a:solidFill>
               </a:rPr>
-              <a:t>Two GPUs need enough work</a:t>
+              <a:t>DataParallel is not model sharding</a:t>
             </a:r>
             <a:endParaRPr lang="en-US" sz="1550" dirty="0"/>
           </a:p>
@@ -9371,7 +9442,7 @@
                   <a:srgbClr val="C7D0D9"/>
                 </a:solidFill>
               </a:rPr>
-              <a:t>Two GPUs took 2.65–3.58× longer.</a:t>
+              <a:t>Each GPU stores the full model and its chunk.</a:t>
             </a:r>
           </a:p>
           <a:p>
@@ -9384,7 +9455,7 @@
                   <a:srgbClr val="C7D0D9"/>
                 </a:solidFill>
               </a:rPr>
-              <a:t>Dataset size adds steps; each GPU still</a:t>
+              <a:t>Here: 1.75–1.92× slower than CPU.</a:t>
             </a:r>
           </a:p>
           <a:p>
@@ -9397,7 +9468,7 @@
                   <a:srgbClr val="C7D0D9"/>
                 </a:solidFill>
               </a:rPr>
-              <a:t>receives only 32 images per batch.</a:t>
+              <a:t>Try a larger CNN / batch; measure again.</a:t>
             </a:r>
             <a:endParaRPr lang="en-US" sz="1250" dirty="0"/>
           </a:p>
@@ -9457,12 +9528,12 @@
               <a:buNone/>
             </a:pPr>
             <a:r>
-              <a:rPr lang="en-US" sz="1300" b="1" dirty="0">
+              <a:rPr lang="en-US" sz="1300" b="1">
                 <a:solidFill>
                   <a:srgbClr val="A3E635"/>
                 </a:solidFill>
               </a:rPr>
-              <a:t>Final design takeaway</a:t>
+              <a:t>Performance takeaway</a:t>
             </a:r>
             <a:endParaRPr lang="en-US" sz="1300" dirty="0"/>
           </a:p>
@@ -9500,7 +9571,7 @@
                   <a:srgbClr val="F4F7FA"/>
                 </a:solidFill>
               </a:rPr>
-              <a:t>Parallel compute helps when useful work exceeds data movement and synchronization.</a:t>
+              <a:t>Use one GPU for this CNN at batch 64. Add GPUs when extra compute exceeds coordination cost.</a:t>
             </a:r>
             <a:endParaRPr lang="en-US" sz="1320" dirty="0"/>
           </a:p>
@@ -9564,7 +9635,7 @@
           </a:prstGeom>
           <a:extLst>
             <a:ext uri="{C572A759-6A51-4108-AA02-DFA0A04FC94B}">
-              <ma14:wrappingTextBoxFlag xmlns="" xmlns:ma14="http://schemas.microsoft.com/office/mac/drawingml/2011/main" val="0"/>
+              <ma14:wrappingTextBoxFlag xmlns:ma14="http://schemas.microsoft.com/office/mac/drawingml/2011/main" xmlns="" val="0"/>
             </a:ext>
           </a:extLst>
         </p:spPr>
@@ -11912,7 +11983,7 @@
           </a:prstGeom>
           <a:extLst>
             <a:ext uri="{C572A759-6A51-4108-AA02-DFA0A04FC94B}">
-              <ma14:wrappingTextBoxFlag xmlns="" xmlns:ma14="http://schemas.microsoft.com/office/mac/drawingml/2011/main" val="0"/>
+              <ma14:wrappingTextBoxFlag xmlns:ma14="http://schemas.microsoft.com/office/mac/drawingml/2011/main" xmlns="" val="0"/>
             </a:ext>
           </a:extLst>
         </p:spPr>
@@ -13949,7 +14020,7 @@
           </a:prstGeom>
           <a:extLst>
             <a:ext uri="{C572A759-6A51-4108-AA02-DFA0A04FC94B}">
-              <ma14:wrappingTextBoxFlag xmlns="" xmlns:ma14="http://schemas.microsoft.com/office/mac/drawingml/2011/main" val="0"/>
+              <ma14:wrappingTextBoxFlag xmlns:ma14="http://schemas.microsoft.com/office/mac/drawingml/2011/main" xmlns="" val="0"/>
             </a:ext>
           </a:extLst>
         </p:spPr>
@@ -15292,7 +15363,7 @@
           </a:prstGeom>
           <a:extLst>
             <a:ext uri="{C572A759-6A51-4108-AA02-DFA0A04FC94B}">
-              <ma14:wrappingTextBoxFlag xmlns="" xmlns:ma14="http://schemas.microsoft.com/office/mac/drawingml/2011/main" val="0"/>
+              <ma14:wrappingTextBoxFlag xmlns:ma14="http://schemas.microsoft.com/office/mac/drawingml/2011/main" xmlns="" val="0"/>
             </a:ext>
           </a:extLst>
         </p:spPr>
@@ -17950,7 +18021,7 @@
           </a:prstGeom>
           <a:extLst>
             <a:ext uri="{C572A759-6A51-4108-AA02-DFA0A04FC94B}">
-              <ma14:wrappingTextBoxFlag xmlns="" xmlns:ma14="http://schemas.microsoft.com/office/mac/drawingml/2011/main" val="0"/>
+              <ma14:wrappingTextBoxFlag xmlns:ma14="http://schemas.microsoft.com/office/mac/drawingml/2011/main" xmlns="" val="0"/>
             </a:ext>
           </a:extLst>
         </p:spPr>
@@ -20673,7 +20744,7 @@
           </a:prstGeom>
           <a:extLst>
             <a:ext uri="{C572A759-6A51-4108-AA02-DFA0A04FC94B}">
-              <ma14:wrappingTextBoxFlag xmlns:ma14="http://schemas.microsoft.com/office/mac/drawingml/2011/main" xmlns="" val="0"/>
+              <ma14:wrappingTextBoxFlag xmlns="" xmlns:ma14="http://schemas.microsoft.com/office/mac/drawingml/2011/main" val="0"/>
             </a:ext>
           </a:extLst>
         </p:spPr>
@@ -23657,7 +23728,7 @@
           </a:prstGeom>
           <a:extLst>
             <a:ext uri="{C572A759-6A51-4108-AA02-DFA0A04FC94B}">
-              <ma14:wrappingTextBoxFlag xmlns="" xmlns:ma14="http://schemas.microsoft.com/office/mac/drawingml/2011/main" val="0"/>
+              <ma14:wrappingTextBoxFlag xmlns:ma14="http://schemas.microsoft.com/office/mac/drawingml/2011/main" xmlns="" val="0"/>
             </a:ext>
           </a:extLst>
         </p:spPr>
@@ -25205,7 +25276,7 @@
           </a:prstGeom>
           <a:extLst>
             <a:ext uri="{C572A759-6A51-4108-AA02-DFA0A04FC94B}">
-              <ma14:wrappingTextBoxFlag xmlns="" xmlns:ma14="http://schemas.microsoft.com/office/mac/drawingml/2011/main" val="0"/>
+              <ma14:wrappingTextBoxFlag xmlns:ma14="http://schemas.microsoft.com/office/mac/drawingml/2011/main" xmlns="" val="0"/>
             </a:ext>
           </a:extLst>
         </p:spPr>
@@ -26508,7 +26579,7 @@
           </a:prstGeom>
           <a:extLst>
             <a:ext uri="{C572A759-6A51-4108-AA02-DFA0A04FC94B}">
-              <ma14:wrappingTextBoxFlag xmlns="" xmlns:ma14="http://schemas.microsoft.com/office/mac/drawingml/2011/main" val="0"/>
+              <ma14:wrappingTextBoxFlag xmlns:ma14="http://schemas.microsoft.com/office/mac/drawingml/2011/main" xmlns="" val="0"/>
             </a:ext>
           </a:extLst>
         </p:spPr>

</xml_diff>